<commit_message>
Add v4 model (stacked GBM + optimal decode) and technical presentation
v4 beats v2 (test MAE 0.275 vs 0.2895) by stacking v2's signals as
out-of-fold features into a multiclass GBM and decoding the predicted
star distribution with the MAE-optimal expected-cost rule instead of a
global rounding threshold. Verified via paired bootstrap and holdout
simulations (ANALYSIS.md §9).

Also adds a second, technically-focused presentation deck (independent
design system) that walks through the four pipeline stages in detail,
with validation compressed to a single slide, plus matching speaker
scripts for both decks.

Co-Authored-By: Claude Sonnet 5 <noreply@anthropic.com>
</commit_message>
<xml_diff>
--- a/SephoBay_Praesentation.pptx
+++ b/SephoBay_Praesentation.pptx
@@ -4,6 +4,9 @@
   <p:sldMasterIdLst>
     <p:sldMasterId id="2147483648" r:id="rId1"/>
   </p:sldMasterIdLst>
+  <p:notesMasterIdLst>
+    <p:notesMasterId r:id="rId10"/>
+  </p:notesMasterIdLst>
   <p:sldIdLst>
     <p:sldId id="256" r:id="rId2"/>
     <p:sldId id="257" r:id="rId3"/>
@@ -14,9 +17,6 @@
     <p:sldId id="262" r:id="rId8"/>
     <p:sldId id="263" r:id="rId9"/>
   </p:sldIdLst>
-  <p:notesMasterIdLst>
-    <p:notesMasterId r:id="rId10"/>
-  </p:notesMasterIdLst>
   <p:sldSz cx="12192000" cy="6858000"/>
   <p:notesSz cx="6858000" cy="12192000"/>
   <p:defaultTextStyle>
@@ -111,13 +111,20 @@
       </a:defRPr>
     </a:lvl9pPr>
   </p:defaultTextStyle>
+  <p:extLst>
+    <p:ext uri="{EFAFB233-063F-42B5-8137-9DF3F51BA10A}">
+      <p15:sldGuideLst xmlns:p15="http://schemas.microsoft.com/office/powerpoint/2012/main"/>
+    </p:ext>
+  </p:extLst>
 </p:presentation>
 </file>
 
 <file path=ppt/charts/chart1.xml><?xml version="1.0" encoding="utf-8"?>
-<c:chartSpace xmlns:c="http://schemas.openxmlformats.org/drawingml/2006/chart" xmlns:a="http://schemas.openxmlformats.org/drawingml/2006/main" xmlns:r="http://schemas.openxmlformats.org/officeDocument/2006/relationships">
+<c:chartSpace xmlns:c="http://schemas.openxmlformats.org/drawingml/2006/chart" xmlns:a="http://schemas.openxmlformats.org/drawingml/2006/main" xmlns:r="http://schemas.openxmlformats.org/officeDocument/2006/relationships" xmlns:c16r2="http://schemas.microsoft.com/office/drawing/2015/06/chart">
   <c:date1904 val="0"/>
+  <c:lang val="de-DE"/>
   <c:roundedCorners val="1"/>
+  <c:style val="2"/>
   <c:chart>
     <c:autoTitleDeleted val="1"/>
     <c:plotArea>
@@ -147,73 +154,45 @@
             <a:effectLst/>
           </c:spPr>
           <c:invertIfNegative val="0"/>
-          <c:dLbls>
-            <c:numFmt formatCode="0.0&quot;%&quot;" sourceLinked="0"/>
-            <c:txPr>
-              <a:bodyPr/>
-              <a:lstStyle/>
-              <a:p>
-                <a:pPr>
-                  <a:defRPr b="0" i="0" strike="noStrike" sz="1000" u="none">
-                    <a:solidFill>
-                      <a:srgbClr val="2E2A2B"/>
-                    </a:solidFill>
-                    <a:latin typeface="Arial"/>
-                  </a:defRPr>
-                </a:pPr>
-              </a:p>
-            </c:txPr>
-            <c:showLegendKey val="0"/>
-            <c:showVal val="1"/>
-            <c:showCatName val="0"/>
-            <c:showSerName val="0"/>
-            <c:showPercent val="0"/>
-            <c:showBubbleSize val="0"/>
-            <c:showLeaderLines val="0"/>
-          </c:dLbls>
           <c:dPt>
             <c:idx val="0"/>
             <c:invertIfNegative val="0"/>
             <c:bubble3D val="0"/>
-            <c:spPr>
-              <a:solidFill>
-                <a:srgbClr val="A26769"/>
-              </a:solidFill>
-              <a:effectLst/>
-            </c:spPr>
+            <c:extLst>
+              <c:ext xmlns:c16="http://schemas.microsoft.com/office/drawing/2014/chart" uri="{C3380CC4-5D6E-409C-BE32-E72D297353CC}">
+                <c16:uniqueId val="{00000001-EF85-4EB6-8BC8-BDD0F02D387C}"/>
+              </c:ext>
+            </c:extLst>
           </c:dPt>
           <c:dPt>
             <c:idx val="1"/>
             <c:invertIfNegative val="0"/>
             <c:bubble3D val="0"/>
-            <c:spPr>
-              <a:solidFill>
-                <a:srgbClr val="A26769"/>
-              </a:solidFill>
-              <a:effectLst/>
-            </c:spPr>
+            <c:extLst>
+              <c:ext xmlns:c16="http://schemas.microsoft.com/office/drawing/2014/chart" uri="{C3380CC4-5D6E-409C-BE32-E72D297353CC}">
+                <c16:uniqueId val="{00000003-EF85-4EB6-8BC8-BDD0F02D387C}"/>
+              </c:ext>
+            </c:extLst>
           </c:dPt>
           <c:dPt>
             <c:idx val="2"/>
             <c:invertIfNegative val="0"/>
             <c:bubble3D val="0"/>
-            <c:spPr>
-              <a:solidFill>
-                <a:srgbClr val="A26769"/>
-              </a:solidFill>
-              <a:effectLst/>
-            </c:spPr>
+            <c:extLst>
+              <c:ext xmlns:c16="http://schemas.microsoft.com/office/drawing/2014/chart" uri="{C3380CC4-5D6E-409C-BE32-E72D297353CC}">
+                <c16:uniqueId val="{00000005-EF85-4EB6-8BC8-BDD0F02D387C}"/>
+              </c:ext>
+            </c:extLst>
           </c:dPt>
           <c:dPt>
             <c:idx val="3"/>
             <c:invertIfNegative val="0"/>
             <c:bubble3D val="0"/>
-            <c:spPr>
-              <a:solidFill>
-                <a:srgbClr val="A26769"/>
-              </a:solidFill>
-              <a:effectLst/>
-            </c:spPr>
+            <c:extLst>
+              <c:ext xmlns:c16="http://schemas.microsoft.com/office/drawing/2014/chart" uri="{C3380CC4-5D6E-409C-BE32-E72D297353CC}">
+                <c16:uniqueId val="{00000007-EF85-4EB6-8BC8-BDD0F02D387C}"/>
+              </c:ext>
+            </c:extLst>
           </c:dPt>
           <c:dPt>
             <c:idx val="4"/>
@@ -225,31 +204,71 @@
               </a:solidFill>
               <a:effectLst/>
             </c:spPr>
+            <c:extLst>
+              <c:ext xmlns:c16="http://schemas.microsoft.com/office/drawing/2014/chart" uri="{C3380CC4-5D6E-409C-BE32-E72D297353CC}">
+                <c16:uniqueId val="{00000009-EF85-4EB6-8BC8-BDD0F02D387C}"/>
+              </c:ext>
+            </c:extLst>
           </c:dPt>
+          <c:dLbls>
+            <c:numFmt formatCode="0.0&quot;%&quot;" sourceLinked="0"/>
+            <c:spPr>
+              <a:noFill/>
+              <a:ln>
+                <a:noFill/>
+              </a:ln>
+              <a:effectLst/>
+            </c:spPr>
+            <c:txPr>
+              <a:bodyPr/>
+              <a:lstStyle/>
+              <a:p>
+                <a:pPr>
+                  <a:defRPr sz="1000" b="0" i="0" u="none" strike="noStrike">
+                    <a:solidFill>
+                      <a:srgbClr val="2E2A2B"/>
+                    </a:solidFill>
+                    <a:latin typeface="Arial"/>
+                  </a:defRPr>
+                </a:pPr>
+                <a:endParaRPr lang="de-DE"/>
+              </a:p>
+            </c:txPr>
+            <c:showLegendKey val="0"/>
+            <c:showVal val="1"/>
+            <c:showCatName val="0"/>
+            <c:showSerName val="0"/>
+            <c:showPercent val="0"/>
+            <c:showBubbleSize val="0"/>
+            <c:showLeaderLines val="0"/>
+            <c:extLst>
+              <c:ext xmlns:c15="http://schemas.microsoft.com/office/drawing/2012/chart" uri="{CE6537A1-D6FC-4f65-9D91-7224C49458BB}">
+                <c15:showLeaderLines val="0"/>
+              </c:ext>
+            </c:extLst>
+          </c:dLbls>
           <c:cat>
-            <c:multiLvlStrRef>
+            <c:strRef>
               <c:f>Sheet1!$A$2:$A$6</c:f>
-              <c:multiLvlStrCache>
+              <c:strCache>
                 <c:ptCount val="5"/>
-                <c:lvl>
-                  <c:pt idx="0">
-                    <c:v>1</c:v>
-                  </c:pt>
-                  <c:pt idx="1">
-                    <c:v>2</c:v>
-                  </c:pt>
-                  <c:pt idx="2">
-                    <c:v>3</c:v>
-                  </c:pt>
-                  <c:pt idx="3">
-                    <c:v>4</c:v>
-                  </c:pt>
-                  <c:pt idx="4">
-                    <c:v>5</c:v>
-                  </c:pt>
-                </c:lvl>
-              </c:multiLvlStrCache>
-            </c:multiLvlStrRef>
+                <c:pt idx="0">
+                  <c:v>1</c:v>
+                </c:pt>
+                <c:pt idx="1">
+                  <c:v>2</c:v>
+                </c:pt>
+                <c:pt idx="2">
+                  <c:v>3</c:v>
+                </c:pt>
+                <c:pt idx="3">
+                  <c:v>4</c:v>
+                </c:pt>
+                <c:pt idx="4">
+                  <c:v>5</c:v>
+                </c:pt>
+              </c:strCache>
+            </c:strRef>
           </c:cat>
           <c:val>
             <c:numRef>
@@ -267,44 +286,31 @@
                   <c:v>4.5</c:v>
                 </c:pt>
                 <c:pt idx="3">
-                  <c:v>16.6</c:v>
+                  <c:v>16.600000000000001</c:v>
                 </c:pt>
                 <c:pt idx="4">
-                  <c:v>74.9</c:v>
+                  <c:v>74.900000000000006</c:v>
                 </c:pt>
               </c:numCache>
             </c:numRef>
           </c:val>
+          <c:extLst>
+            <c:ext xmlns:c16="http://schemas.microsoft.com/office/drawing/2014/chart" uri="{C3380CC4-5D6E-409C-BE32-E72D297353CC}">
+              <c16:uniqueId val="{0000000A-EF85-4EB6-8BC8-BDD0F02D387C}"/>
+            </c:ext>
+          </c:extLst>
         </c:ser>
         <c:dLbls>
-          <c:numFmt formatCode="0.0&quot;%&quot;" sourceLinked="0"/>
-          <c:txPr>
-            <a:bodyPr/>
-            <a:lstStyle/>
-            <a:p>
-              <a:pPr>
-                <a:defRPr b="0" i="0" strike="noStrike" sz="1000" u="none">
-                  <a:solidFill>
-                    <a:srgbClr val="2E2A2B"/>
-                  </a:solidFill>
-                  <a:latin typeface="Arial"/>
-                </a:defRPr>
-              </a:pPr>
-            </a:p>
-          </c:txPr>
           <c:showLegendKey val="0"/>
           <c:showVal val="1"/>
           <c:showCatName val="0"/>
           <c:showSerName val="0"/>
           <c:showPercent val="0"/>
           <c:showBubbleSize val="0"/>
-          <c:showLeaderLines val="0"/>
         </c:dLbls>
         <c:gapWidth val="40"/>
-        <c:overlap val="0"/>
         <c:axId val="2094734554"/>
         <c:axId val="2094734552"/>
-        <c:axId val="2094734556"/>
       </c:barChart>
       <c:catAx>
         <c:axId val="2094734554"/>
@@ -345,6 +351,7 @@
         <c:crosses val="autoZero"/>
         <c:auto val="1"/>
         <c:lblAlgn val="ctr"/>
+        <c:lblOffset val="100"/>
         <c:noMultiLvlLbl val="1"/>
       </c:catAx>
       <c:valAx>
@@ -358,30 +365,6 @@
         <c:majorTickMark val="out"/>
         <c:minorTickMark val="none"/>
         <c:tickLblPos val="nextTo"/>
-        <c:spPr>
-          <a:ln w="12700" cap="flat">
-            <a:solidFill>
-              <a:srgbClr val="888888"/>
-            </a:solidFill>
-            <a:prstDash val="solid"/>
-            <a:round/>
-          </a:ln>
-        </c:spPr>
-        <c:txPr>
-          <a:bodyPr/>
-          <a:lstStyle/>
-          <a:p>
-            <a:pPr>
-              <a:defRPr sz="1200" b="0" i="0" u="none" strike="noStrike">
-                <a:solidFill>
-                  <a:srgbClr val="000000"/>
-                </a:solidFill>
-                <a:latin typeface="Arial"/>
-              </a:defRPr>
-            </a:pPr>
-            <a:endParaRPr lang="en-US"/>
-          </a:p>
-        </c:txPr>
         <c:crossAx val="2094734554"/>
         <c:crosses val="autoZero"/>
         <c:crossBetween val="between"/>
@@ -396,6 +379,7 @@
     </c:plotArea>
     <c:plotVisOnly val="1"/>
     <c:dispBlanksAs val="span"/>
+    <c:showDLblsOverMax val="1"/>
   </c:chart>
   <c:spPr>
     <a:solidFill>
@@ -413,9 +397,11 @@
 </file>
 
 <file path=ppt/charts/chart2.xml><?xml version="1.0" encoding="utf-8"?>
-<c:chartSpace xmlns:c="http://schemas.openxmlformats.org/drawingml/2006/chart" xmlns:a="http://schemas.openxmlformats.org/drawingml/2006/main" xmlns:r="http://schemas.openxmlformats.org/officeDocument/2006/relationships">
+<c:chartSpace xmlns:c="http://schemas.openxmlformats.org/drawingml/2006/chart" xmlns:a="http://schemas.openxmlformats.org/drawingml/2006/main" xmlns:r="http://schemas.openxmlformats.org/officeDocument/2006/relationships" xmlns:c16r2="http://schemas.microsoft.com/office/drawing/2015/06/chart">
   <c:date1904 val="0"/>
+  <c:lang val="de-DE"/>
   <c:roundedCorners val="1"/>
+  <c:style val="2"/>
   <c:chart>
     <c:autoTitleDeleted val="1"/>
     <c:plotArea>
@@ -447,18 +433,26 @@
           <c:invertIfNegative val="0"/>
           <c:dLbls>
             <c:numFmt formatCode="0.000" sourceLinked="0"/>
+            <c:spPr>
+              <a:noFill/>
+              <a:ln>
+                <a:noFill/>
+              </a:ln>
+              <a:effectLst/>
+            </c:spPr>
             <c:txPr>
               <a:bodyPr/>
               <a:lstStyle/>
               <a:p>
                 <a:pPr>
-                  <a:defRPr b="1" i="0" strike="noStrike" sz="1300" u="none">
+                  <a:defRPr sz="1300" b="1" i="0" u="none" strike="noStrike">
                     <a:solidFill>
                       <a:srgbClr val="2E2A2B"/>
                     </a:solidFill>
                     <a:latin typeface="Arial"/>
                   </a:defRPr>
                 </a:pPr>
+                <a:endParaRPr lang="de-DE"/>
               </a:p>
             </c:txPr>
             <c:showLegendKey val="0"/>
@@ -468,35 +462,41 @@
             <c:showPercent val="0"/>
             <c:showBubbleSize val="0"/>
             <c:showLeaderLines val="0"/>
+            <c:extLst>
+              <c:ext xmlns:c15="http://schemas.microsoft.com/office/drawing/2012/chart" uri="{CE6537A1-D6FC-4f65-9D91-7224C49458BB}">
+                <c15:showLeaderLines val="0"/>
+              </c:ext>
+            </c:extLst>
           </c:dLbls>
           <c:cat>
-            <c:multiLvlStrRef>
-              <c:f>Sheet1!$A$2:$A$5</c:f>
-              <c:multiLvlStrCache>
-                <c:ptCount val="4"/>
-                <c:lvl>
-                  <c:pt idx="0">
-                    <c:v>Immer 5</c:v>
-                  </c:pt>
-                  <c:pt idx="1">
-                    <c:v>Bias-Backbone</c:v>
-                  </c:pt>
-                  <c:pt idx="2">
-                    <c:v>+ Content + Blend</c:v>
-                  </c:pt>
-                  <c:pt idx="3">
-                    <c:v>Final (+ Schwelle)</c:v>
-                  </c:pt>
-                </c:lvl>
-              </c:multiLvlStrCache>
-            </c:multiLvlStrRef>
+            <c:strRef>
+              <c:f>Sheet1!$A$2:$A$6</c:f>
+              <c:strCache>
+                <c:ptCount val="5"/>
+                <c:pt idx="0">
+                  <c:v>Immer 5</c:v>
+                </c:pt>
+                <c:pt idx="1">
+                  <c:v>Bias-Backbone</c:v>
+                </c:pt>
+                <c:pt idx="2">
+                  <c:v>+ Content + Blend</c:v>
+                </c:pt>
+                <c:pt idx="3">
+                  <c:v>+ Schwelle (v2)</c:v>
+                </c:pt>
+                <c:pt idx="4">
+                  <c:v>Final: opt. Entscheidung</c:v>
+                </c:pt>
+              </c:strCache>
+            </c:strRef>
           </c:cat>
           <c:val>
             <c:numRef>
-              <c:f>Sheet1!$B$2:$B$5</c:f>
+              <c:f>Sheet1!$B$2:$B$6</c:f>
               <c:numCache>
                 <c:formatCode>General</c:formatCode>
-                <c:ptCount val="4"/>
+                <c:ptCount val="5"/>
                 <c:pt idx="0">
                   <c:v>0.371</c:v>
                 </c:pt>
@@ -509,39 +509,29 @@
                 <c:pt idx="3">
                   <c:v>0.2895</c:v>
                 </c:pt>
+                <c:pt idx="4">
+                  <c:v>0.275</c:v>
+                </c:pt>
               </c:numCache>
             </c:numRef>
           </c:val>
+          <c:extLst>
+            <c:ext xmlns:c16="http://schemas.microsoft.com/office/drawing/2014/chart" uri="{C3380CC4-5D6E-409C-BE32-E72D297353CC}">
+              <c16:uniqueId val="{00000000-17A7-41C6-9260-DBCF554CFE60}"/>
+            </c:ext>
+          </c:extLst>
         </c:ser>
         <c:dLbls>
-          <c:numFmt formatCode="0.000" sourceLinked="0"/>
-          <c:txPr>
-            <a:bodyPr/>
-            <a:lstStyle/>
-            <a:p>
-              <a:pPr>
-                <a:defRPr b="1" i="0" strike="noStrike" sz="1300" u="none">
-                  <a:solidFill>
-                    <a:srgbClr val="2E2A2B"/>
-                  </a:solidFill>
-                  <a:latin typeface="Arial"/>
-                </a:defRPr>
-              </a:pPr>
-            </a:p>
-          </c:txPr>
           <c:showLegendKey val="0"/>
           <c:showVal val="1"/>
           <c:showCatName val="0"/>
           <c:showSerName val="0"/>
           <c:showPercent val="0"/>
           <c:showBubbleSize val="0"/>
-          <c:showLeaderLines val="0"/>
         </c:dLbls>
         <c:gapWidth val="55"/>
-        <c:overlap val="0"/>
         <c:axId val="2094734554"/>
         <c:axId val="2094734552"/>
-        <c:axId val="2094734556"/>
       </c:barChart>
       <c:catAx>
         <c:axId val="2094734554"/>
@@ -582,6 +572,7 @@
         <c:crosses val="autoZero"/>
         <c:auto val="1"/>
         <c:lblAlgn val="ctr"/>
+        <c:lblOffset val="100"/>
         <c:noMultiLvlLbl val="1"/>
       </c:catAx>
       <c:valAx>
@@ -597,30 +588,6 @@
         <c:majorTickMark val="out"/>
         <c:minorTickMark val="none"/>
         <c:tickLblPos val="low"/>
-        <c:spPr>
-          <a:ln w="12700" cap="flat">
-            <a:solidFill>
-              <a:srgbClr val="888888"/>
-            </a:solidFill>
-            <a:prstDash val="solid"/>
-            <a:round/>
-          </a:ln>
-        </c:spPr>
-        <c:txPr>
-          <a:bodyPr/>
-          <a:lstStyle/>
-          <a:p>
-            <a:pPr>
-              <a:defRPr sz="1200" b="0" i="0" u="none" strike="noStrike">
-                <a:solidFill>
-                  <a:srgbClr val="000000"/>
-                </a:solidFill>
-                <a:latin typeface="Arial"/>
-              </a:defRPr>
-            </a:pPr>
-            <a:endParaRPr lang="en-US"/>
-          </a:p>
-        </c:txPr>
         <c:crossAx val="2094734554"/>
         <c:crosses val="autoZero"/>
         <c:crossBetween val="between"/>
@@ -635,6 +602,7 @@
     </c:plotArea>
     <c:plotVisOnly val="1"/>
     <c:dispBlanksAs val="span"/>
+    <c:showDLblsOverMax val="1"/>
   </c:chart>
   <c:spPr>
     <a:solidFill>
@@ -673,234 +641,10 @@
           <a:chExt cx="0" cy="0"/>
         </a:xfrm>
       </p:grpSpPr>
-      <p:sp>
-        <p:nvSpPr>
-          <p:cNvPr id="2" name="Header Placeholder 1"/>
-          <p:cNvSpPr>
-            <a:spLocks noGrp="1"/>
-          </p:cNvSpPr>
-          <p:nvPr>
-            <p:ph type="hdr" sz="quarter"/>
-          </p:nvPr>
-        </p:nvSpPr>
-        <p:spPr>
-          <a:xfrm>
-            <a:off x="0" y="0"/>
-            <a:ext cx="2971800" cy="458788"/>
-          </a:xfrm>
-          <a:prstGeom prst="rect">
-            <a:avLst/>
-          </a:prstGeom>
-        </p:spPr>
-        <p:txBody>
-          <a:bodyPr vert="horz" lIns="91440" tIns="45720" rIns="91440" bIns="45720" rtlCol="0"/>
-          <a:lstStyle>
-            <a:lvl1pPr algn="l">
-              <a:defRPr sz="1200"/>
-            </a:lvl1pPr>
-          </a:lstStyle>
-          <a:p>
-            <a:endParaRPr lang="en-US"/>
-          </a:p>
-        </p:txBody>
-      </p:sp>
-      <p:sp>
-        <p:nvSpPr>
-          <p:cNvPr id="3" name="Date Placeholder 2"/>
-          <p:cNvSpPr>
-            <a:spLocks noGrp="1"/>
-          </p:cNvSpPr>
-          <p:nvPr>
-            <p:ph type="dt" idx="1"/>
-          </p:nvPr>
-        </p:nvSpPr>
-        <p:spPr>
-          <a:xfrm>
-            <a:off x="3884613" y="0"/>
-            <a:ext cx="2971800" cy="458788"/>
-          </a:xfrm>
-          <a:prstGeom prst="rect">
-            <a:avLst/>
-          </a:prstGeom>
-        </p:spPr>
-        <p:txBody>
-          <a:bodyPr vert="horz" lIns="91440" tIns="45720" rIns="91440" bIns="45720" rtlCol="0"/>
-          <a:lstStyle>
-            <a:lvl1pPr algn="r">
-              <a:defRPr sz="1200"/>
-            </a:lvl1pPr>
-          </a:lstStyle>
-          <a:p>
-            <a:fld id="{5282F153-3F37-0F45-9E97-73ACFA13230C}" type="datetimeFigureOut">
-              <a:rPr lang="en-US"/>
-              <a:t>7/23/19</a:t>
-            </a:fld>
-            <a:endParaRPr lang="en-US"/>
-          </a:p>
-        </p:txBody>
-      </p:sp>
-      <p:sp>
-        <p:nvSpPr>
-          <p:cNvPr id="4" name="Slide Image Placeholder 3"/>
-          <p:cNvSpPr>
-            <a:spLocks noGrp="1" noRot="1" noChangeAspect="1"/>
-          </p:cNvSpPr>
-          <p:nvPr>
-            <p:ph type="sldImg" idx="2"/>
-          </p:nvPr>
-        </p:nvSpPr>
-        <p:spPr>
-          <a:xfrm>
-            <a:off x="685800" y="1143000"/>
-            <a:ext cx="5486400" cy="3086100"/>
-          </a:xfrm>
-          <a:prstGeom prst="rect">
-            <a:avLst/>
-          </a:prstGeom>
-          <a:noFill/>
-          <a:ln w="12700">
-            <a:solidFill>
-              <a:prstClr val="black"/>
-            </a:solidFill>
-          </a:ln>
-        </p:spPr>
-        <p:txBody>
-          <a:bodyPr vert="horz" lIns="91440" tIns="45720" rIns="91440" bIns="45720" rtlCol="0" anchor="ctr"/>
-          <a:lstStyle/>
-          <a:p>
-            <a:endParaRPr lang="en-US"/>
-          </a:p>
-        </p:txBody>
-      </p:sp>
-      <p:sp>
-        <p:nvSpPr>
-          <p:cNvPr id="5" name="Notes Placeholder 4"/>
-          <p:cNvSpPr>
-            <a:spLocks noGrp="1"/>
-          </p:cNvSpPr>
-          <p:nvPr>
-            <p:ph type="body" sz="quarter" idx="3"/>
-          </p:nvPr>
-        </p:nvSpPr>
-        <p:spPr>
-          <a:xfrm>
-            <a:off x="685800" y="4400550"/>
-            <a:ext cx="5486400" cy="3600450"/>
-          </a:xfrm>
-          <a:prstGeom prst="rect">
-            <a:avLst/>
-          </a:prstGeom>
-        </p:spPr>
-        <p:txBody>
-          <a:bodyPr vert="horz" lIns="91440" tIns="45720" rIns="91440" bIns="45720" rtlCol="0"/>
-          <a:lstStyle/>
-          <a:p>
-            <a:pPr lvl="0"/>
-            <a:r>
-              <a:rPr lang="en-US"/>
-              <a:t>Click to edit Master text styles</a:t>
-            </a:r>
-          </a:p>
-          <a:p>
-            <a:pPr lvl="1"/>
-            <a:r>
-              <a:rPr lang="en-US"/>
-              <a:t>Second level</a:t>
-            </a:r>
-          </a:p>
-          <a:p>
-            <a:pPr lvl="2"/>
-            <a:r>
-              <a:rPr lang="en-US"/>
-              <a:t>Third level</a:t>
-            </a:r>
-          </a:p>
-          <a:p>
-            <a:pPr lvl="3"/>
-            <a:r>
-              <a:rPr lang="en-US"/>
-              <a:t>Fourth level</a:t>
-            </a:r>
-          </a:p>
-          <a:p>
-            <a:pPr lvl="4"/>
-            <a:r>
-              <a:rPr lang="en-US"/>
-              <a:t>Fifth level</a:t>
-            </a:r>
-          </a:p>
-        </p:txBody>
-      </p:sp>
-      <p:sp>
-        <p:nvSpPr>
-          <p:cNvPr id="6" name="Footer Placeholder 5"/>
-          <p:cNvSpPr>
-            <a:spLocks noGrp="1"/>
-          </p:cNvSpPr>
-          <p:nvPr>
-            <p:ph type="ftr" sz="quarter" idx="4"/>
-          </p:nvPr>
-        </p:nvSpPr>
-        <p:spPr>
-          <a:xfrm>
-            <a:off x="0" y="8685213"/>
-            <a:ext cx="2971800" cy="458787"/>
-          </a:xfrm>
-          <a:prstGeom prst="rect">
-            <a:avLst/>
-          </a:prstGeom>
-        </p:spPr>
-        <p:txBody>
-          <a:bodyPr vert="horz" lIns="91440" tIns="45720" rIns="91440" bIns="45720" rtlCol="0" anchor="b"/>
-          <a:lstStyle>
-            <a:lvl1pPr algn="l">
-              <a:defRPr sz="1200"/>
-            </a:lvl1pPr>
-          </a:lstStyle>
-          <a:p>
-            <a:endParaRPr lang="en-US"/>
-          </a:p>
-        </p:txBody>
-      </p:sp>
-      <p:sp>
-        <p:nvSpPr>
-          <p:cNvPr id="7" name="Slide Number Placeholder 6"/>
-          <p:cNvSpPr>
-            <a:spLocks noGrp="1"/>
-          </p:cNvSpPr>
-          <p:nvPr>
-            <p:ph type="sldNum" sz="quarter" idx="5"/>
-          </p:nvPr>
-        </p:nvSpPr>
-        <p:spPr>
-          <a:xfrm>
-            <a:off x="3884613" y="8685213"/>
-            <a:ext cx="2971800" cy="458787"/>
-          </a:xfrm>
-          <a:prstGeom prst="rect">
-            <a:avLst/>
-          </a:prstGeom>
-        </p:spPr>
-        <p:txBody>
-          <a:bodyPr vert="horz" lIns="91440" tIns="45720" rIns="91440" bIns="45720" rtlCol="0" anchor="b"/>
-          <a:lstStyle>
-            <a:lvl1pPr algn="r">
-              <a:defRPr sz="1200"/>
-            </a:lvl1pPr>
-          </a:lstStyle>
-          <a:p>
-            <a:fld id="{CE5E9CC1-C706-0F49-92D6-E571CC5EEA8F}" type="slidenum">
-              <a:rPr lang="en-US"/>
-              <a:t>‹#›</a:t>
-            </a:fld>
-            <a:endParaRPr lang="en-US"/>
-          </a:p>
-        </p:txBody>
-      </p:sp>
     </p:spTree>
     <p:extLst>
       <p:ext uri="{BB962C8B-B14F-4D97-AF65-F5344CB8AC3E}">
-        <p14:creationId xmlns:p14="http://schemas.microsoft.com/office/powerpoint/2010/main" val="1024086991"/>
+        <p14:creationId xmlns:p14="http://schemas.microsoft.com/office/powerpoint/2010/main" val="3872728187"/>
       </p:ext>
     </p:extLst>
   </p:cSld>
@@ -1045,10 +789,8 @@
           <a:lstStyle/>
           <a:p>
             <a:r>
-              <a:rPr lang="en-US" dirty="0"/>
-              <a:t>Begrüßung. Wir präsentieren unser Recommender System für SephoBay. Ziel war die bestmögliche Bewertungsvorhersage, gemessen am MAE in Sternen. Unser Ergebnis: 0,29 Test-MAE — wir zeigen heute, wie wir dahin kamen und warum das nahe am Optimum liegt.</a:t>
-            </a:r>
-            <a:endParaRPr lang="en-US" dirty="0"/>
+              <a:t>Begrüßung. Wir präsentieren unser Recommender System für SephoBay. Ziel laut Briefing: die bestmögliche Empfehlungsgüte, gemessen am MAE in gerundeten Sternen — im direkten Wettbewerb mit den anderen Gruppen. Unser Ergebnis: 0,275 Test-MAE. Wir zeigen heute, wie wir dahin kamen und warum das nahe am Machbaren liegt.</a:t>
+            </a:r>
           </a:p>
         </p:txBody>
       </p:sp>
@@ -1133,10 +875,8 @@
           <a:lstStyle/>
           <a:p>
             <a:r>
-              <a:rPr lang="en-US" dirty="0"/>
-              <a:t>Die Geschäftslage: Kundenbindung leidet, weil Nutzer relevante Produkte nicht finden. Der Auftrag ist ein Recommender. Entscheidend für den Wettbewerb: die Zielgröße ist der MAE in Sternen, und zwar GERUNDET auf ganze Sterne. Diese Rundung ist später unser wichtigster Hebel.</a:t>
-            </a:r>
-            <a:endParaRPr lang="en-US" dirty="0"/>
+              <a:t>Die Geschäftslage aus dem Briefing: Im großen Sortiment finden Kund:innen relevante Produkte kaum noch — Interaktion, Zufriedenheit und Kundenbindung sinken; gefunden werden meist nur Bestseller. Der Auftrag: ein Recommender System, das Bewertungen vorhersagt. Bewertet wird der MAE in GERUNDETEN Sternen — auf dem Testdatensatz und zusätzlich auf einem streng unter Verschluss gehaltenen Evaluationsdatensatz der Auftraggeber. Diese Rundung ist später unser wichtigster Hebel.</a:t>
+            </a:r>
           </a:p>
         </p:txBody>
       </p:sp>
@@ -1224,7 +964,6 @@
               <a:rPr lang="en-US" dirty="0"/>
               <a:t>798 Nutzer, 622 Produkte, knapp 25.000 Bewertungen, Skala 0 bis 5. Die wichtigste Beobachtung: 75% aller Bewertungen sind 5 Sterne. Dadurch ist 'immer 5 raten' schon bei MAE 0,37. Nach dem Runden zählt nicht Feinheit, sondern die Entscheidung 5-oder-nicht. Daran richtet sich unser ganzer Ansatz aus.</a:t>
             </a:r>
-            <a:endParaRPr lang="en-US" dirty="0"/>
           </a:p>
         </p:txBody>
       </p:sp>
@@ -1309,10 +1048,8 @@
           <a:lstStyle/>
           <a:p>
             <a:r>
-              <a:rPr lang="en-US" dirty="0"/>
-              <a:t>Vier Bausteine: 1) Bias-Modell als robuste Basis. 2) Content-Korrektur für Personalisierung. 3) Ein schlanker Blend, der nur hilfreiche Teile behält. 4) Der metrik-optimierte Schwellenwert. Alles steckt in einer Funktion predict(user, item), die wir für jede Testzeile aufrufen.</a:t>
-            </a:r>
-            <a:endParaRPr lang="en-US" dirty="0"/>
+              <a:t>Vier Bausteine: 1) Regularisiertes Bias-Modell als robuste Basis. 2) Content-Korrektur für Personalisierung — unsere kreative Einbindung von Content-Based Filtering. 3) Ein Modell lernt aus allen Signalen die volle Wahrscheinlichkeitsverteilung über 1–5 Sterne. 4) Daraus wählen wir pro Kunde-Produkt-Paar den Stern mit dem kleinsten erwarteten Fehler — die MAE-optimale Entscheidung. Alles steckt in einer Funktion predict(user, item), die automatisiert über alle Testdaten läuft.</a:t>
+            </a:r>
           </a:p>
         </p:txBody>
       </p:sp>
@@ -1397,10 +1134,8 @@
           <a:lstStyle/>
           <a:p>
             <a:r>
-              <a:rPr lang="en-US" dirty="0"/>
-              <a:t>Zwei kreative Schritte. Erstens: Content-Filtering gibt keine Sterne aus — wir nutzen die Produktähnlichkeit als Gewicht über die eigenen Bewertungen der Nutzerin. Das ist die im Briefing ausdrücklich gewünschte kreative Idee. Zweitens, und das ist der größte Hebel: der Rundungs-Schwellenwert. Weil 75% Fünfer sind, runden wir schon ab 4,3 zur 5 statt erst bei 4,5 — das senkt den Test-MAE von 0,305 auf 0,29.</a:t>
-            </a:r>
-            <a:endParaRPr lang="en-US" dirty="0"/>
+              <a:t>Zwei kreative Schritte. Erstens: Content-Filtering gibt keine Sterne aus — wir nutzen die Produktähnlichkeit als Gewicht in einem gewichteten Mittel über die eigenen Bewertungen der Nutzer:in. Genau die im Briefing ausdrücklich gewünschte kreative Einbindung. Zweitens, der größte Hebel: Weil 75 % aller Bewertungen Fünfer sind, sind die Fehlerkosten asymmetrisch. Erst haben wir den Rundungs-Schwellenwert optimiert (zur 5 ab 4,3 statt 4,5), dann die Idee konsequent zu Ende gedacht: die volle Sterne-Verteilung vorhersagen und pro Kunde-Produkt-Paar optimal entscheiden. Das brachte den Test-MAE von 0,305 auf 0,275.</a:t>
+            </a:r>
           </a:p>
         </p:txBody>
       </p:sp>
@@ -1485,10 +1220,8 @@
           <a:lstStyle/>
           <a:p>
             <a:r>
-              <a:rPr lang="en-US" dirty="0"/>
-              <a:t>Das Kernergebnis: 0,29 Test-MAE. Zum Vergleich: 'immer 5' liegt bei 0,37, die reinen Kurs-Methoden bei 0,31. Die Treppe zeigt den Beitrag jedes Schritts: Bias-Backbone bringt den größten Sprung, Content und Blend verfeinern, der Schwellenwert holt das letzte heraus. Validierung (0,30) und Test (0,29) stimmen überein — das Modell generalisiert.</a:t>
-            </a:r>
-            <a:endParaRPr lang="en-US" dirty="0"/>
+              <a:t>Das Kernergebnis: 0,275 Test-MAE. Zum Vergleich: 'immer 5' liegt bei 0,37, die reinen Kurs-Methoden bei 0,31. Die Treppe zeigt jeden Schritt: das Bias-Backbone bringt den größten Sprung, Content und Blend verfeinern, die metrik-optimierte Schwelle bringt 0,29 — und die optimale Entscheidung je Paar 0,275. Abgesichert: ein Bootstrap-Konfidenzintervall und Holdout-Simulationen bestätigen den Vorsprung — das sollte also auch auf dem geheimen Evaluationsdatensatz halten.</a:t>
+            </a:r>
           </a:p>
         </p:txBody>
       </p:sp>
@@ -1573,10 +1306,8 @@
           <a:lstStyle/>
           <a:p>
             <a:r>
-              <a:rPr lang="en-US" dirty="0"/>
-              <a:t>Wir wollten sicher sein, nichts zu verpassen. Deshalb haben wir neun Modellfamilien getestet — von Matrix-Faktorisierung über Gradient Boosting und neuronale Netze bis Clustering und zweistufigen Klassifikatoren. Alle landen zwischen 0,30 und 0,35; keine schlägt uns. Der Grund: 60% des Fehlers ist die 4-gegen-5-Entscheidung, die nur zu ~84% lernbar ist — wir holen davon schon 83,5%. Der Rest ist echtes Rauschen. Werte unter 0,25 wären ein Warnsignal für einen Messfehler.</a:t>
-            </a:r>
-            <a:endParaRPr lang="en-US" dirty="0"/>
+              <a:t>Wir wollten sicher sein, nichts zu verpassen: neun Modellfamilien getestet — von Matrix-Faktorisierung über Gradient Boosting und neuronale Netze bis Clustering. Als 'Regression + Rundung' landen alle zwischen 0,30 und 0,35. Der Durchbruch kam nicht durch ein komplexeres Modell, sondern durch eine bessere Entscheidung: 60 % des Restfehlers ist die 4-gegen-5-Grenze, und die ist nur zu etwa 85 % lernbar — genau dort holt unser finales Modell mit 85,0 % (statt 82,8 %) den Vorsprung. Der Rest ist irreduzibles Rauschen: MAE um 0,20 ist mit diesen Daten nicht erreichbar. Einordnung mit Demut (unsere eigene Untergrenzen-Schätzung wurde einmal nach unten korrigiert): Der Test-MAE auf ~3.000 Zeilen streut um ± 0,02 — Werte um 0,25 können also Stichprobenglück sein. Erst deutlich darunter würden wir zuerst die Methodik hinterfragen (fehlende Rundung, Datenleck).</a:t>
+            </a:r>
           </a:p>
         </p:txBody>
       </p:sp>
@@ -1661,10 +1392,8 @@
           <a:lstStyle/>
           <a:p>
             <a:r>
-              <a:rPr lang="en-US" dirty="0"/>
-              <a:t>Zusammenfassung für den Vorstand: Das Bias-Modell trägt die Hauptlast, die Feinarbeit kommt aus einem weichen Content-Signal und der metrik-gerechten Rundung — nicht aus teureren Modellen. 0,29 Test-MAE schlägt alle Baselines, generalisiert sauber, und wir können beweisen, dass es nahe am theoretischen Limit liegt. Empfehlung: dieses Modell einsetzen. Danke — gerne Fragen.</a:t>
-            </a:r>
-            <a:endParaRPr lang="en-US" dirty="0"/>
+              <a:t>Fazit für den Vorstand: eine robuste Basis, eine kreative Content-Einbindung und die MAE-optimale Entscheidung pro Kunde-Produkt-Paar ergeben 0,275 Test-MAE — statistisch abgesichert und nachweislich nahe am Machbaren. Unsere Empfehlung: das System produktiv einsetzen, damit Kund:innen relevante Produkte finden — für mehr Zufriedenheit und Kundenbindung. Vielen Dank — Fragen?</a:t>
+            </a:r>
           </a:p>
         </p:txBody>
       </p:sp>
@@ -1737,6 +1466,11 @@
 <file path=ppt/slideMasters/slideMaster1.xml><?xml version="1.0" encoding="utf-8"?>
 <p:sldMaster xmlns:a="http://schemas.openxmlformats.org/drawingml/2006/main" xmlns:r="http://schemas.openxmlformats.org/officeDocument/2006/relationships" xmlns:p="http://schemas.openxmlformats.org/presentationml/2006/main">
   <p:cSld>
+    <p:bg>
+      <p:bgRef idx="1001">
+        <a:schemeClr val="bg1"/>
+      </p:bgRef>
+    </p:bg>
     <p:spTree>
       <p:nvGrpSpPr>
         <p:cNvPr id="1" name=""/>
@@ -2019,6 +1753,7 @@
         <a:solidFill>
           <a:srgbClr val="6D2E46"/>
         </a:solidFill>
+        <a:effectLst/>
       </p:bgPr>
     </p:bg>
     <p:spTree>
@@ -2054,6 +1789,13 @@
           </a:solidFill>
           <a:ln/>
         </p:spPr>
+        <p:txBody>
+          <a:bodyPr/>
+          <a:lstStyle/>
+          <a:p>
+            <a:endParaRPr lang="de-DE"/>
+          </a:p>
+        </p:txBody>
       </p:sp>
       <p:sp>
         <p:nvSpPr>
@@ -2074,6 +1816,13 @@
           </a:solidFill>
           <a:ln/>
         </p:spPr>
+        <p:txBody>
+          <a:bodyPr/>
+          <a:lstStyle/>
+          <a:p>
+            <a:endParaRPr lang="de-DE"/>
+          </a:p>
+        </p:txBody>
       </p:sp>
       <p:sp>
         <p:nvSpPr>
@@ -2096,11 +1845,11 @@
           <a:bodyPr wrap="square" rtlCol="0" anchor="ctr"/>
           <a:lstStyle/>
           <a:p>
-            <a:pPr indent="0" marL="0">
-              <a:buNone/>
-            </a:pPr>
-            <a:r>
-              <a:rPr lang="en-US" sz="1300" b="1" spc="200" kern="0" dirty="0">
+            <a:pPr marL="0" indent="0">
+              <a:buNone/>
+            </a:pPr>
+            <a:r>
+              <a:rPr lang="en-US" sz="1300" b="1" kern="0" spc="200" dirty="0">
                 <a:solidFill>
                   <a:srgbClr val="ECE2D0"/>
                 </a:solidFill>
@@ -2135,7 +1884,7 @@
           <a:bodyPr wrap="square" rtlCol="0" anchor="ctr"/>
           <a:lstStyle/>
           <a:p>
-            <a:pPr indent="0" marL="0">
+            <a:pPr marL="0" indent="0">
               <a:lnSpc>
                 <a:spcPct val="95000"/>
               </a:lnSpc>
@@ -2155,7 +1904,7 @@
             <a:endParaRPr lang="en-US" sz="5000" dirty="0"/>
           </a:p>
           <a:p>
-            <a:pPr indent="0" marL="0">
+            <a:pPr marL="0" indent="0">
               <a:lnSpc>
                 <a:spcPct val="95000"/>
               </a:lnSpc>
@@ -2197,7 +1946,7 @@
           <a:bodyPr wrap="square" rtlCol="0" anchor="ctr"/>
           <a:lstStyle/>
           <a:p>
-            <a:pPr indent="0" marL="0">
+            <a:pPr marL="0" indent="0">
               <a:buNone/>
             </a:pPr>
             <a:r>
@@ -2236,13 +1985,20 @@
           </a:solidFill>
           <a:ln/>
           <a:effectLst>
-            <a:outerShdw sx="100000" sy="100000" kx="0" ky="0" algn="bl" rotWithShape="0" blurRad="88900" dist="38100" dir="5400000">
+            <a:outerShdw blurRad="88900" dist="38100" dir="5400000" algn="bl" rotWithShape="0">
               <a:srgbClr val="000000">
                 <a:alpha val="14000"/>
               </a:srgbClr>
             </a:outerShdw>
           </a:effectLst>
         </p:spPr>
+        <p:txBody>
+          <a:bodyPr/>
+          <a:lstStyle/>
+          <a:p>
+            <a:endParaRPr lang="de-DE"/>
+          </a:p>
+        </p:txBody>
       </p:sp>
       <p:sp>
         <p:nvSpPr>
@@ -2265,7 +2021,7 @@
           <a:bodyPr wrap="square" rtlCol="0" anchor="ctr"/>
           <a:lstStyle/>
           <a:p>
-            <a:pPr algn="ctr" indent="0" marL="0">
+            <a:pPr marL="0" indent="0" algn="ctr">
               <a:buNone/>
             </a:pPr>
             <a:r>
@@ -2277,7 +2033,7 @@
                 <a:ea typeface="Cambria" pitchFamily="34" charset="-122"/>
                 <a:cs typeface="Cambria" pitchFamily="34" charset="-120"/>
               </a:rPr>
-              <a:t>0,29</a:t>
+              <a:t>0,275</a:t>
             </a:r>
             <a:endParaRPr lang="en-US" sz="4600" dirty="0"/>
           </a:p>
@@ -2304,7 +2060,7 @@
           <a:bodyPr wrap="square" rtlCol="0" anchor="ctr"/>
           <a:lstStyle/>
           <a:p>
-            <a:pPr algn="ctr" indent="0" marL="0">
+            <a:pPr marL="0" indent="0" algn="ctr">
               <a:buNone/>
             </a:pPr>
             <a:r>
@@ -2343,7 +2099,7 @@
           <a:bodyPr wrap="square" rtlCol="0" anchor="ctr"/>
           <a:lstStyle/>
           <a:p>
-            <a:pPr indent="0" marL="0">
+            <a:pPr marL="0" indent="0">
               <a:buNone/>
             </a:pPr>
             <a:r>
@@ -2355,7 +2111,7 @@
                 <a:ea typeface="Calibri" pitchFamily="34" charset="-122"/>
                 <a:cs typeface="Calibri" pitchFamily="34" charset="-120"/>
               </a:rPr>
-              <a:t>Gruppe SephoBay   ·   15.06.2026</a:t>
+              <a:t>Gruppe SephoBay   ·   16.07.2026</a:t>
             </a:r>
             <a:endParaRPr lang="en-US" sz="1300" dirty="0"/>
           </a:p>
@@ -2377,6 +2133,7 @@
         <a:solidFill>
           <a:srgbClr val="FFFFFF"/>
         </a:solidFill>
+        <a:effectLst/>
       </p:bgPr>
     </p:bg>
     <p:spTree>
@@ -2414,11 +2171,11 @@
           <a:bodyPr wrap="square" rtlCol="0" anchor="ctr"/>
           <a:lstStyle/>
           <a:p>
-            <a:pPr indent="0" marL="0">
-              <a:buNone/>
-            </a:pPr>
-            <a:r>
-              <a:rPr lang="en-US" sz="1200" b="1" spc="300" kern="0" dirty="0">
+            <a:pPr marL="0" indent="0">
+              <a:buNone/>
+            </a:pPr>
+            <a:r>
+              <a:rPr lang="en-US" sz="1200" b="1" kern="0" spc="300" dirty="0">
                 <a:solidFill>
                   <a:srgbClr val="A26769"/>
                 </a:solidFill>
@@ -2453,7 +2210,7 @@
           <a:bodyPr wrap="square" rtlCol="0" anchor="ctr"/>
           <a:lstStyle/>
           <a:p>
-            <a:pPr indent="0" marL="0">
+            <a:pPr marL="0" indent="0">
               <a:buNone/>
             </a:pPr>
             <a:r>
@@ -2490,6 +2247,13 @@
           </a:solidFill>
           <a:ln/>
         </p:spPr>
+        <p:txBody>
+          <a:bodyPr/>
+          <a:lstStyle/>
+          <a:p>
+            <a:endParaRPr lang="de-DE"/>
+          </a:p>
+        </p:txBody>
       </p:sp>
       <p:sp>
         <p:nvSpPr>
@@ -2512,7 +2276,7 @@
           <a:bodyPr wrap="square" rtlCol="0" anchor="ctr"/>
           <a:lstStyle/>
           <a:p>
-            <a:pPr algn="ctr" indent="0" marL="0">
+            <a:pPr marL="0" indent="0" algn="ctr">
               <a:buNone/>
             </a:pPr>
             <a:r>
@@ -2551,7 +2315,7 @@
           <a:bodyPr wrap="square" rtlCol="0" anchor="ctr"/>
           <a:lstStyle/>
           <a:p>
-            <a:pPr indent="0" marL="0">
+            <a:pPr marL="0" indent="0">
               <a:buNone/>
             </a:pPr>
             <a:r>
@@ -2590,7 +2354,7 @@
           <a:bodyPr wrap="square" rtlCol="0" anchor="ctr"/>
           <a:lstStyle/>
           <a:p>
-            <a:pPr indent="0" marL="0">
+            <a:pPr marL="0" indent="0">
               <a:buNone/>
             </a:pPr>
             <a:r>
@@ -2627,6 +2391,13 @@
           </a:solidFill>
           <a:ln/>
         </p:spPr>
+        <p:txBody>
+          <a:bodyPr/>
+          <a:lstStyle/>
+          <a:p>
+            <a:endParaRPr lang="de-DE"/>
+          </a:p>
+        </p:txBody>
       </p:sp>
       <p:sp>
         <p:nvSpPr>
@@ -2649,7 +2420,7 @@
           <a:bodyPr wrap="square" rtlCol="0" anchor="ctr"/>
           <a:lstStyle/>
           <a:p>
-            <a:pPr algn="ctr" indent="0" marL="0">
+            <a:pPr marL="0" indent="0" algn="ctr">
               <a:buNone/>
             </a:pPr>
             <a:r>
@@ -2688,7 +2459,7 @@
           <a:bodyPr wrap="square" rtlCol="0" anchor="ctr"/>
           <a:lstStyle/>
           <a:p>
-            <a:pPr indent="0" marL="0">
+            <a:pPr marL="0" indent="0">
               <a:buNone/>
             </a:pPr>
             <a:r>
@@ -2727,7 +2498,7 @@
           <a:bodyPr wrap="square" rtlCol="0" anchor="ctr"/>
           <a:lstStyle/>
           <a:p>
-            <a:pPr indent="0" marL="0">
+            <a:pPr marL="0" indent="0">
               <a:buNone/>
             </a:pPr>
             <a:r>
@@ -2764,6 +2535,13 @@
           </a:solidFill>
           <a:ln/>
         </p:spPr>
+        <p:txBody>
+          <a:bodyPr/>
+          <a:lstStyle/>
+          <a:p>
+            <a:endParaRPr lang="de-DE"/>
+          </a:p>
+        </p:txBody>
       </p:sp>
       <p:sp>
         <p:nvSpPr>
@@ -2786,7 +2564,7 @@
           <a:bodyPr wrap="square" rtlCol="0" anchor="ctr"/>
           <a:lstStyle/>
           <a:p>
-            <a:pPr algn="ctr" indent="0" marL="0">
+            <a:pPr marL="0" indent="0" algn="ctr">
               <a:buNone/>
             </a:pPr>
             <a:r>
@@ -2825,7 +2603,7 @@
           <a:bodyPr wrap="square" rtlCol="0" anchor="ctr"/>
           <a:lstStyle/>
           <a:p>
-            <a:pPr indent="0" marL="0">
+            <a:pPr marL="0" indent="0">
               <a:buNone/>
             </a:pPr>
             <a:r>
@@ -2864,7 +2642,7 @@
           <a:bodyPr wrap="square" rtlCol="0" anchor="ctr"/>
           <a:lstStyle/>
           <a:p>
-            <a:pPr indent="0" marL="0">
+            <a:pPr marL="0" indent="0">
               <a:buNone/>
             </a:pPr>
             <a:r>
@@ -2903,13 +2681,20 @@
           </a:solidFill>
           <a:ln/>
           <a:effectLst>
-            <a:outerShdw sx="100000" sy="100000" kx="0" ky="0" algn="bl" rotWithShape="0" blurRad="88900" dist="38100" dir="5400000">
+            <a:outerShdw blurRad="88900" dist="38100" dir="5400000" algn="bl" rotWithShape="0">
               <a:srgbClr val="000000">
                 <a:alpha val="14000"/>
               </a:srgbClr>
             </a:outerShdw>
           </a:effectLst>
         </p:spPr>
+        <p:txBody>
+          <a:bodyPr/>
+          <a:lstStyle/>
+          <a:p>
+            <a:endParaRPr lang="de-DE"/>
+          </a:p>
+        </p:txBody>
       </p:sp>
       <p:sp>
         <p:nvSpPr>
@@ -2932,11 +2717,11 @@
           <a:bodyPr wrap="square" rtlCol="0" anchor="ctr"/>
           <a:lstStyle/>
           <a:p>
-            <a:pPr indent="0" marL="0">
-              <a:buNone/>
-            </a:pPr>
-            <a:r>
-              <a:rPr lang="en-US" sz="1300" b="1" spc="300" kern="0" dirty="0">
+            <a:pPr marL="0" indent="0">
+              <a:buNone/>
+            </a:pPr>
+            <a:r>
+              <a:rPr lang="en-US" sz="1300" b="1" kern="0" spc="300" dirty="0">
                 <a:solidFill>
                   <a:srgbClr val="A26769"/>
                 </a:solidFill>
@@ -2971,7 +2756,7 @@
           <a:bodyPr wrap="square" rtlCol="0" anchor="ctr"/>
           <a:lstStyle/>
           <a:p>
-            <a:pPr indent="0" marL="0">
+            <a:pPr marL="0" indent="0">
               <a:lnSpc>
                 <a:spcPct val="98000"/>
               </a:lnSpc>
@@ -2991,7 +2776,7 @@
             <a:endParaRPr lang="en-US" sz="2600" dirty="0"/>
           </a:p>
           <a:p>
-            <a:pPr indent="0" marL="0">
+            <a:pPr marL="0" indent="0">
               <a:lnSpc>
                 <a:spcPct val="98000"/>
               </a:lnSpc>
@@ -3033,7 +2818,7 @@
           <a:bodyPr wrap="square" rtlCol="0" anchor="ctr"/>
           <a:lstStyle/>
           <a:p>
-            <a:pPr indent="0" marL="0">
+            <a:pPr marL="0" indent="0">
               <a:buNone/>
             </a:pPr>
             <a:r>
@@ -3047,9 +2832,6 @@
               </a:rPr>
               <a:t>Minimaler </a:t>
             </a:r>
-            <a:pPr indent="0" marL="0">
-              <a:buNone/>
-            </a:pPr>
             <a:r>
               <a:rPr lang="en-US" sz="1500" b="1" dirty="0">
                 <a:solidFill>
@@ -3061,9 +2843,6 @@
               </a:rPr>
               <a:t>MAE in Sternen</a:t>
             </a:r>
-            <a:pPr indent="0" marL="0">
-              <a:buNone/>
-            </a:pPr>
             <a:r>
               <a:rPr lang="en-US" sz="1500" dirty="0">
                 <a:solidFill>
@@ -3100,7 +2879,7 @@
           <a:bodyPr wrap="square" rtlCol="0" anchor="ctr"/>
           <a:lstStyle/>
           <a:p>
-            <a:pPr indent="0" marL="0">
+            <a:pPr marL="0" indent="0">
               <a:buNone/>
             </a:pPr>
             <a:r>
@@ -3139,7 +2918,7 @@
           <a:bodyPr wrap="square" rtlCol="0" anchor="ctr"/>
           <a:lstStyle/>
           <a:p>
-            <a:pPr indent="0" marL="0">
+            <a:pPr marL="0" indent="0">
               <a:buNone/>
             </a:pPr>
             <a:r>
@@ -3178,7 +2957,7 @@
           <a:bodyPr wrap="square" rtlCol="0" anchor="ctr"/>
           <a:lstStyle/>
           <a:p>
-            <a:pPr algn="r" indent="0" marL="0">
+            <a:pPr marL="0" indent="0" algn="r">
               <a:buNone/>
             </a:pPr>
             <a:r>
@@ -3217,7 +2996,7 @@
           <a:bodyPr wrap="square" rtlCol="0" anchor="ctr"/>
           <a:lstStyle/>
           <a:p>
-            <a:pPr algn="l" indent="0" marL="0">
+            <a:pPr marL="0" indent="0" algn="l">
               <a:buNone/>
             </a:pPr>
             <a:r>
@@ -3251,6 +3030,7 @@
         <a:solidFill>
           <a:srgbClr val="FFFFFF"/>
         </a:solidFill>
+        <a:effectLst/>
       </p:bgPr>
     </p:bg>
     <p:spTree>
@@ -3288,11 +3068,11 @@
           <a:bodyPr wrap="square" rtlCol="0" anchor="ctr"/>
           <a:lstStyle/>
           <a:p>
-            <a:pPr indent="0" marL="0">
-              <a:buNone/>
-            </a:pPr>
-            <a:r>
-              <a:rPr lang="en-US" sz="1200" b="1" spc="300" kern="0" dirty="0">
+            <a:pPr marL="0" indent="0">
+              <a:buNone/>
+            </a:pPr>
+            <a:r>
+              <a:rPr lang="en-US" sz="1200" b="1" kern="0" spc="300" dirty="0">
                 <a:solidFill>
                   <a:srgbClr val="A26769"/>
                 </a:solidFill>
@@ -3327,7 +3107,7 @@
           <a:bodyPr wrap="square" rtlCol="0" anchor="ctr"/>
           <a:lstStyle/>
           <a:p>
-            <a:pPr indent="0" marL="0">
+            <a:pPr marL="0" indent="0">
               <a:buNone/>
             </a:pPr>
             <a:r>
@@ -3366,6 +3146,13 @@
           </a:solidFill>
           <a:ln/>
         </p:spPr>
+        <p:txBody>
+          <a:bodyPr/>
+          <a:lstStyle/>
+          <a:p>
+            <a:endParaRPr lang="de-DE"/>
+          </a:p>
+        </p:txBody>
       </p:sp>
       <p:sp>
         <p:nvSpPr>
@@ -3388,7 +3175,7 @@
           <a:bodyPr wrap="square" rtlCol="0" anchor="ctr"/>
           <a:lstStyle/>
           <a:p>
-            <a:pPr algn="ctr" indent="0" marL="0">
+            <a:pPr marL="0" indent="0" algn="ctr">
               <a:buNone/>
             </a:pPr>
             <a:r>
@@ -3427,7 +3214,7 @@
           <a:bodyPr wrap="square" rtlCol="0" anchor="ctr"/>
           <a:lstStyle/>
           <a:p>
-            <a:pPr algn="ctr" indent="0" marL="0">
+            <a:pPr marL="0" indent="0" algn="ctr">
               <a:buNone/>
             </a:pPr>
             <a:r>
@@ -3466,6 +3253,13 @@
           </a:solidFill>
           <a:ln/>
         </p:spPr>
+        <p:txBody>
+          <a:bodyPr/>
+          <a:lstStyle/>
+          <a:p>
+            <a:endParaRPr lang="de-DE"/>
+          </a:p>
+        </p:txBody>
       </p:sp>
       <p:sp>
         <p:nvSpPr>
@@ -3488,7 +3282,7 @@
           <a:bodyPr wrap="square" rtlCol="0" anchor="ctr"/>
           <a:lstStyle/>
           <a:p>
-            <a:pPr algn="ctr" indent="0" marL="0">
+            <a:pPr marL="0" indent="0" algn="ctr">
               <a:buNone/>
             </a:pPr>
             <a:r>
@@ -3527,7 +3321,7 @@
           <a:bodyPr wrap="square" rtlCol="0" anchor="ctr"/>
           <a:lstStyle/>
           <a:p>
-            <a:pPr algn="ctr" indent="0" marL="0">
+            <a:pPr marL="0" indent="0" algn="ctr">
               <a:buNone/>
             </a:pPr>
             <a:r>
@@ -3566,6 +3360,13 @@
           </a:solidFill>
           <a:ln/>
         </p:spPr>
+        <p:txBody>
+          <a:bodyPr/>
+          <a:lstStyle/>
+          <a:p>
+            <a:endParaRPr lang="de-DE"/>
+          </a:p>
+        </p:txBody>
       </p:sp>
       <p:sp>
         <p:nvSpPr>
@@ -3588,7 +3389,7 @@
           <a:bodyPr wrap="square" rtlCol="0" anchor="ctr"/>
           <a:lstStyle/>
           <a:p>
-            <a:pPr algn="ctr" indent="0" marL="0">
+            <a:pPr marL="0" indent="0" algn="ctr">
               <a:buNone/>
             </a:pPr>
             <a:r>
@@ -3627,7 +3428,7 @@
           <a:bodyPr wrap="square" rtlCol="0" anchor="ctr"/>
           <a:lstStyle/>
           <a:p>
-            <a:pPr algn="ctr" indent="0" marL="0">
+            <a:pPr marL="0" indent="0" algn="ctr">
               <a:buNone/>
             </a:pPr>
             <a:r>
@@ -3666,6 +3467,13 @@
           </a:solidFill>
           <a:ln/>
         </p:spPr>
+        <p:txBody>
+          <a:bodyPr/>
+          <a:lstStyle/>
+          <a:p>
+            <a:endParaRPr lang="de-DE"/>
+          </a:p>
+        </p:txBody>
       </p:sp>
       <p:sp>
         <p:nvSpPr>
@@ -3688,7 +3496,7 @@
           <a:bodyPr wrap="square" rtlCol="0" anchor="ctr"/>
           <a:lstStyle/>
           <a:p>
-            <a:pPr algn="ctr" indent="0" marL="0">
+            <a:pPr marL="0" indent="0" algn="ctr">
               <a:buNone/>
             </a:pPr>
             <a:r>
@@ -3727,7 +3535,7 @@
           <a:bodyPr wrap="square" rtlCol="0" anchor="ctr"/>
           <a:lstStyle/>
           <a:p>
-            <a:pPr algn="ctr" indent="0" marL="0">
+            <a:pPr marL="0" indent="0" algn="ctr">
               <a:buNone/>
             </a:pPr>
             <a:r>
@@ -3766,7 +3574,7 @@
           <a:bodyPr wrap="square" rtlCol="0" anchor="ctr"/>
           <a:lstStyle/>
           <a:p>
-            <a:pPr indent="0" marL="0">
+            <a:pPr marL="0" indent="0">
               <a:buNone/>
             </a:pPr>
             <a:r>
@@ -3786,7 +3594,7 @@
       </p:sp>
       <p:graphicFrame>
         <p:nvGraphicFramePr>
-          <p:cNvPr id="17" name="Chart 0" descr=""/>
+          <p:cNvPr id="17" name="Chart 0"/>
           <p:cNvGraphicFramePr/>
           <p:nvPr/>
         </p:nvGraphicFramePr>
@@ -3794,9 +3602,9 @@
           <a:off x="457200" y="4617720"/>
           <a:ext cx="5303520" cy="1828800"/>
         </p:xfrm>
-        <a:graphic xmlns:a="http://schemas.openxmlformats.org/drawingml/2006/main">
+        <a:graphic>
           <a:graphicData uri="http://schemas.openxmlformats.org/drawingml/2006/chart">
-            <c:chart xmlns:c="http://schemas.openxmlformats.org/drawingml/2006/chart" r:id="rId1"/>
+            <c:chart xmlns:c="http://schemas.openxmlformats.org/drawingml/2006/chart" xmlns:r="http://schemas.openxmlformats.org/officeDocument/2006/relationships" r:id="rId3"/>
           </a:graphicData>
         </a:graphic>
       </p:graphicFrame>
@@ -3821,13 +3629,20 @@
           </a:solidFill>
           <a:ln/>
           <a:effectLst>
-            <a:outerShdw sx="100000" sy="100000" kx="0" ky="0" algn="bl" rotWithShape="0" blurRad="88900" dist="38100" dir="5400000">
+            <a:outerShdw blurRad="88900" dist="38100" dir="5400000" algn="bl" rotWithShape="0">
               <a:srgbClr val="000000">
                 <a:alpha val="14000"/>
               </a:srgbClr>
             </a:outerShdw>
           </a:effectLst>
         </p:spPr>
+        <p:txBody>
+          <a:bodyPr/>
+          <a:lstStyle/>
+          <a:p>
+            <a:endParaRPr lang="de-DE"/>
+          </a:p>
+        </p:txBody>
       </p:sp>
       <p:sp>
         <p:nvSpPr>
@@ -3850,7 +3665,7 @@
           <a:bodyPr wrap="square" rtlCol="0" anchor="ctr"/>
           <a:lstStyle/>
           <a:p>
-            <a:pPr indent="0" marL="0">
+            <a:pPr marL="0" indent="0">
               <a:buNone/>
             </a:pPr>
             <a:r>
@@ -3889,7 +3704,7 @@
           <a:bodyPr wrap="square" rtlCol="0" anchor="ctr"/>
           <a:lstStyle/>
           <a:p>
-            <a:pPr indent="0" marL="0">
+            <a:pPr marL="0" indent="0">
               <a:buNone/>
             </a:pPr>
             <a:r>
@@ -3928,7 +3743,7 @@
           <a:bodyPr wrap="square" rtlCol="0" anchor="ctr"/>
           <a:lstStyle/>
           <a:p>
-            <a:pPr indent="0" marL="0">
+            <a:pPr marL="0" indent="0">
               <a:buNone/>
             </a:pPr>
             <a:r>
@@ -3942,9 +3757,6 @@
               </a:rPr>
               <a:t>Folge: </a:t>
             </a:r>
-            <a:pPr indent="0" marL="0">
-              <a:buNone/>
-            </a:pPr>
             <a:r>
               <a:rPr lang="en-US" sz="1500" dirty="0">
                 <a:solidFill>
@@ -3956,9 +3768,6 @@
               </a:rPr>
               <a:t>Das Problem ist keine Regression, sondern eine Entscheidung — </a:t>
             </a:r>
-            <a:pPr indent="0" marL="0">
-              <a:buNone/>
-            </a:pPr>
             <a:r>
               <a:rPr lang="en-US" sz="1500" b="1" i="1" dirty="0">
                 <a:solidFill>
@@ -3995,7 +3804,7 @@
           <a:bodyPr wrap="square" rtlCol="0" anchor="ctr"/>
           <a:lstStyle/>
           <a:p>
-            <a:pPr indent="0" marL="0">
+            <a:pPr marL="0" indent="0">
               <a:buNone/>
             </a:pPr>
             <a:r>
@@ -4009,9 +3818,6 @@
               </a:rPr>
               <a:t>Trivial-Baseline „immer 5 raten“  </a:t>
             </a:r>
-            <a:pPr indent="0" marL="0">
-              <a:buNone/>
-            </a:pPr>
             <a:r>
               <a:rPr lang="en-US" sz="1500" b="1" dirty="0">
                 <a:solidFill>
@@ -4048,7 +3854,7 @@
           <a:bodyPr wrap="square" rtlCol="0" anchor="ctr"/>
           <a:lstStyle/>
           <a:p>
-            <a:pPr algn="r" indent="0" marL="0">
+            <a:pPr marL="0" indent="0" algn="r">
               <a:buNone/>
             </a:pPr>
             <a:r>
@@ -4087,7 +3893,7 @@
           <a:bodyPr wrap="square" rtlCol="0" anchor="ctr"/>
           <a:lstStyle/>
           <a:p>
-            <a:pPr algn="l" indent="0" marL="0">
+            <a:pPr marL="0" indent="0" algn="l">
               <a:buNone/>
             </a:pPr>
             <a:r>
@@ -4121,6 +3927,7 @@
         <a:solidFill>
           <a:srgbClr val="FFFFFF"/>
         </a:solidFill>
+        <a:effectLst/>
       </p:bgPr>
     </p:bg>
     <p:spTree>
@@ -4158,11 +3965,11 @@
           <a:bodyPr wrap="square" rtlCol="0" anchor="ctr"/>
           <a:lstStyle/>
           <a:p>
-            <a:pPr indent="0" marL="0">
-              <a:buNone/>
-            </a:pPr>
-            <a:r>
-              <a:rPr lang="en-US" sz="1200" b="1" spc="300" kern="0" dirty="0">
+            <a:pPr marL="0" indent="0">
+              <a:buNone/>
+            </a:pPr>
+            <a:r>
+              <a:rPr lang="en-US" sz="1200" b="1" kern="0" spc="300" dirty="0">
                 <a:solidFill>
                   <a:srgbClr val="A26769"/>
                 </a:solidFill>
@@ -4197,7 +4004,7 @@
           <a:bodyPr wrap="square" rtlCol="0" anchor="ctr"/>
           <a:lstStyle/>
           <a:p>
-            <a:pPr indent="0" marL="0">
+            <a:pPr marL="0" indent="0">
               <a:buNone/>
             </a:pPr>
             <a:r>
@@ -4209,7 +4016,7 @@
                 <a:ea typeface="Cambria" pitchFamily="34" charset="-122"/>
                 <a:cs typeface="Cambria" pitchFamily="34" charset="-120"/>
               </a:rPr>
-              <a:t>Starke Basis, gezielte Korrektur, kluge Rundung</a:t>
+              <a:t>Starke Basis, gezielte Korrektur, optimale Entscheidung</a:t>
             </a:r>
             <a:endParaRPr lang="en-US" sz="3000" dirty="0"/>
           </a:p>
@@ -4236,13 +4043,20 @@
           </a:solidFill>
           <a:ln/>
           <a:effectLst>
-            <a:outerShdw sx="100000" sy="100000" kx="0" ky="0" algn="bl" rotWithShape="0" blurRad="88900" dist="38100" dir="5400000">
+            <a:outerShdw blurRad="88900" dist="38100" dir="5400000" algn="bl" rotWithShape="0">
               <a:srgbClr val="000000">
                 <a:alpha val="14000"/>
               </a:srgbClr>
             </a:outerShdw>
           </a:effectLst>
         </p:spPr>
+        <p:txBody>
+          <a:bodyPr/>
+          <a:lstStyle/>
+          <a:p>
+            <a:endParaRPr lang="de-DE"/>
+          </a:p>
+        </p:txBody>
       </p:sp>
       <p:sp>
         <p:nvSpPr>
@@ -4263,6 +4077,13 @@
           </a:solidFill>
           <a:ln/>
         </p:spPr>
+        <p:txBody>
+          <a:bodyPr/>
+          <a:lstStyle/>
+          <a:p>
+            <a:endParaRPr lang="de-DE"/>
+          </a:p>
+        </p:txBody>
       </p:sp>
       <p:sp>
         <p:nvSpPr>
@@ -4285,7 +4106,7 @@
           <a:bodyPr wrap="square" rtlCol="0" anchor="ctr"/>
           <a:lstStyle/>
           <a:p>
-            <a:pPr algn="ctr" indent="0" marL="0">
+            <a:pPr marL="0" indent="0" algn="ctr">
               <a:buNone/>
             </a:pPr>
             <a:r>
@@ -4324,7 +4145,7 @@
           <a:bodyPr wrap="square" rtlCol="0" anchor="t"/>
           <a:lstStyle/>
           <a:p>
-            <a:pPr indent="0" marL="0">
+            <a:pPr marL="0" indent="0">
               <a:buNone/>
             </a:pPr>
             <a:r>
@@ -4363,7 +4184,7 @@
           <a:bodyPr wrap="square" rtlCol="0" anchor="ctr"/>
           <a:lstStyle/>
           <a:p>
-            <a:pPr indent="0" marL="0">
+            <a:pPr marL="0" indent="0">
               <a:buNone/>
             </a:pPr>
             <a:r>
@@ -4402,7 +4223,7 @@
           <a:bodyPr wrap="square" rtlCol="0" anchor="ctr"/>
           <a:lstStyle/>
           <a:p>
-            <a:pPr algn="ctr" indent="0" marL="0">
+            <a:pPr marL="0" indent="0" algn="ctr">
               <a:buNone/>
             </a:pPr>
             <a:r>
@@ -4441,13 +4262,20 @@
           </a:solidFill>
           <a:ln/>
           <a:effectLst>
-            <a:outerShdw sx="100000" sy="100000" kx="0" ky="0" algn="bl" rotWithShape="0" blurRad="88900" dist="38100" dir="5400000">
+            <a:outerShdw blurRad="88900" dist="38100" dir="5400000" algn="bl" rotWithShape="0">
               <a:srgbClr val="000000">
                 <a:alpha val="14000"/>
               </a:srgbClr>
             </a:outerShdw>
           </a:effectLst>
         </p:spPr>
+        <p:txBody>
+          <a:bodyPr/>
+          <a:lstStyle/>
+          <a:p>
+            <a:endParaRPr lang="de-DE"/>
+          </a:p>
+        </p:txBody>
       </p:sp>
       <p:sp>
         <p:nvSpPr>
@@ -4468,6 +4296,13 @@
           </a:solidFill>
           <a:ln/>
         </p:spPr>
+        <p:txBody>
+          <a:bodyPr/>
+          <a:lstStyle/>
+          <a:p>
+            <a:endParaRPr lang="de-DE"/>
+          </a:p>
+        </p:txBody>
       </p:sp>
       <p:sp>
         <p:nvSpPr>
@@ -4490,7 +4325,7 @@
           <a:bodyPr wrap="square" rtlCol="0" anchor="ctr"/>
           <a:lstStyle/>
           <a:p>
-            <a:pPr algn="ctr" indent="0" marL="0">
+            <a:pPr marL="0" indent="0" algn="ctr">
               <a:buNone/>
             </a:pPr>
             <a:r>
@@ -4529,7 +4364,7 @@
           <a:bodyPr wrap="square" rtlCol="0" anchor="t"/>
           <a:lstStyle/>
           <a:p>
-            <a:pPr indent="0" marL="0">
+            <a:pPr marL="0" indent="0">
               <a:buNone/>
             </a:pPr>
             <a:r>
@@ -4568,7 +4403,7 @@
           <a:bodyPr wrap="square" rtlCol="0" anchor="ctr"/>
           <a:lstStyle/>
           <a:p>
-            <a:pPr indent="0" marL="0">
+            <a:pPr marL="0" indent="0">
               <a:buNone/>
             </a:pPr>
             <a:r>
@@ -4607,7 +4442,7 @@
           <a:bodyPr wrap="square" rtlCol="0" anchor="ctr"/>
           <a:lstStyle/>
           <a:p>
-            <a:pPr algn="ctr" indent="0" marL="0">
+            <a:pPr marL="0" indent="0" algn="ctr">
               <a:buNone/>
             </a:pPr>
             <a:r>
@@ -4646,13 +4481,20 @@
           </a:solidFill>
           <a:ln/>
           <a:effectLst>
-            <a:outerShdw sx="100000" sy="100000" kx="0" ky="0" algn="bl" rotWithShape="0" blurRad="88900" dist="38100" dir="5400000">
+            <a:outerShdw blurRad="88900" dist="38100" dir="5400000" algn="bl" rotWithShape="0">
               <a:srgbClr val="000000">
                 <a:alpha val="14000"/>
               </a:srgbClr>
             </a:outerShdw>
           </a:effectLst>
         </p:spPr>
+        <p:txBody>
+          <a:bodyPr/>
+          <a:lstStyle/>
+          <a:p>
+            <a:endParaRPr lang="de-DE"/>
+          </a:p>
+        </p:txBody>
       </p:sp>
       <p:sp>
         <p:nvSpPr>
@@ -4673,6 +4515,13 @@
           </a:solidFill>
           <a:ln/>
         </p:spPr>
+        <p:txBody>
+          <a:bodyPr/>
+          <a:lstStyle/>
+          <a:p>
+            <a:endParaRPr lang="de-DE"/>
+          </a:p>
+        </p:txBody>
       </p:sp>
       <p:sp>
         <p:nvSpPr>
@@ -4695,7 +4544,7 @@
           <a:bodyPr wrap="square" rtlCol="0" anchor="ctr"/>
           <a:lstStyle/>
           <a:p>
-            <a:pPr algn="ctr" indent="0" marL="0">
+            <a:pPr marL="0" indent="0" algn="ctr">
               <a:buNone/>
             </a:pPr>
             <a:r>
@@ -4734,7 +4583,7 @@
           <a:bodyPr wrap="square" rtlCol="0" anchor="t"/>
           <a:lstStyle/>
           <a:p>
-            <a:pPr indent="0" marL="0">
+            <a:pPr marL="0" indent="0">
               <a:buNone/>
             </a:pPr>
             <a:r>
@@ -4746,7 +4595,7 @@
                 <a:ea typeface="Cambria" pitchFamily="34" charset="-122"/>
                 <a:cs typeface="Cambria" pitchFamily="34" charset="-120"/>
               </a:rPr>
-              <a:t>Lean Blend</a:t>
+              <a:t>Sterne-Verteilung</a:t>
             </a:r>
             <a:endParaRPr lang="en-US" sz="1600" dirty="0"/>
           </a:p>
@@ -4773,7 +4622,7 @@
           <a:bodyPr wrap="square" rtlCol="0" anchor="ctr"/>
           <a:lstStyle/>
           <a:p>
-            <a:pPr indent="0" marL="0">
+            <a:pPr marL="0" indent="0">
               <a:buNone/>
             </a:pPr>
             <a:r>
@@ -4785,7 +4634,29 @@
                 <a:ea typeface="Calibri" pitchFamily="34" charset="-122"/>
                 <a:cs typeface="Calibri" pitchFamily="34" charset="-120"/>
               </a:rPr>
-              <a:t>Gewichtete Kombination — nur Komponenten, die auf Validierung wirklich helfen.</a:t>
+              <a:t>Ein Modell lernt aus allen Signalen die </a:t>
+            </a:r>
+            <a:r>
+              <a:rPr lang="en-US" sz="1250" dirty="0" err="1">
+                <a:solidFill>
+                  <a:srgbClr val="2E2A2B"/>
+                </a:solidFill>
+                <a:latin typeface="Calibri" pitchFamily="34" charset="0"/>
+                <a:ea typeface="Calibri" pitchFamily="34" charset="-122"/>
+                <a:cs typeface="Calibri" pitchFamily="34" charset="-120"/>
+              </a:rPr>
+              <a:t>volle Verteilung</a:t>
+            </a:r>
+            <a:r>
+              <a:rPr lang="en-US" sz="1250" dirty="0">
+                <a:solidFill>
+                  <a:srgbClr val="2E2A2B"/>
+                </a:solidFill>
+                <a:latin typeface="Calibri" pitchFamily="34" charset="0"/>
+                <a:ea typeface="Calibri" pitchFamily="34" charset="-122"/>
+                <a:cs typeface="Calibri" pitchFamily="34" charset="-120"/>
+              </a:rPr>
+              <a:t> P(1–5 Sterne) je Kunde-Produkt-Paar.</a:t>
             </a:r>
             <a:endParaRPr lang="en-US" sz="1250" dirty="0"/>
           </a:p>
@@ -4812,7 +4683,7 @@
           <a:bodyPr wrap="square" rtlCol="0" anchor="ctr"/>
           <a:lstStyle/>
           <a:p>
-            <a:pPr algn="ctr" indent="0" marL="0">
+            <a:pPr marL="0" indent="0" algn="ctr">
               <a:buNone/>
             </a:pPr>
             <a:r>
@@ -4851,13 +4722,20 @@
           </a:solidFill>
           <a:ln/>
           <a:effectLst>
-            <a:outerShdw sx="100000" sy="100000" kx="0" ky="0" algn="bl" rotWithShape="0" blurRad="88900" dist="38100" dir="5400000">
+            <a:outerShdw blurRad="88900" dist="38100" dir="5400000" algn="bl" rotWithShape="0">
               <a:srgbClr val="000000">
                 <a:alpha val="14000"/>
               </a:srgbClr>
             </a:outerShdw>
           </a:effectLst>
         </p:spPr>
+        <p:txBody>
+          <a:bodyPr/>
+          <a:lstStyle/>
+          <a:p>
+            <a:endParaRPr lang="de-DE"/>
+          </a:p>
+        </p:txBody>
       </p:sp>
       <p:sp>
         <p:nvSpPr>
@@ -4878,6 +4756,13 @@
           </a:solidFill>
           <a:ln/>
         </p:spPr>
+        <p:txBody>
+          <a:bodyPr/>
+          <a:lstStyle/>
+          <a:p>
+            <a:endParaRPr lang="de-DE"/>
+          </a:p>
+        </p:txBody>
       </p:sp>
       <p:sp>
         <p:nvSpPr>
@@ -4900,7 +4785,7 @@
           <a:bodyPr wrap="square" rtlCol="0" anchor="ctr"/>
           <a:lstStyle/>
           <a:p>
-            <a:pPr algn="ctr" indent="0" marL="0">
+            <a:pPr marL="0" indent="0" algn="ctr">
               <a:buNone/>
             </a:pPr>
             <a:r>
@@ -4939,7 +4824,7 @@
           <a:bodyPr wrap="square" rtlCol="0" anchor="t"/>
           <a:lstStyle/>
           <a:p>
-            <a:pPr indent="0" marL="0">
+            <a:pPr marL="0" indent="0">
               <a:buNone/>
             </a:pPr>
             <a:r>
@@ -4951,7 +4836,7 @@
                 <a:ea typeface="Cambria" pitchFamily="34" charset="-122"/>
                 <a:cs typeface="Cambria" pitchFamily="34" charset="-120"/>
               </a:rPr>
-              <a:t>Schwellenwert</a:t>
+              <a:t>Entscheidung</a:t>
             </a:r>
             <a:endParaRPr lang="en-US" sz="1600" dirty="0"/>
           </a:p>
@@ -4978,7 +4863,7 @@
           <a:bodyPr wrap="square" rtlCol="0" anchor="ctr"/>
           <a:lstStyle/>
           <a:p>
-            <a:pPr indent="0" marL="0">
+            <a:pPr marL="0" indent="0">
               <a:buNone/>
             </a:pPr>
             <a:r>
@@ -4990,7 +4875,7 @@
                 <a:ea typeface="Calibri" pitchFamily="34" charset="-122"/>
                 <a:cs typeface="Calibri" pitchFamily="34" charset="-120"/>
               </a:rPr>
-              <a:t>Metrik-optimierte Rundung in Sterne — der größte Einzel-Hebel.</a:t>
+              <a:t>Pro Paar der Stern mit dem kleinsten erwarteten Fehler — der größte Hebel.</a:t>
             </a:r>
             <a:endParaRPr lang="en-US" sz="1250" dirty="0"/>
           </a:p>
@@ -5017,7 +4902,7 @@
           <a:bodyPr wrap="square" rtlCol="0" anchor="ctr"/>
           <a:lstStyle/>
           <a:p>
-            <a:pPr indent="0" marL="0">
+            <a:pPr marL="0" indent="0">
               <a:buNone/>
             </a:pPr>
             <a:r>
@@ -5056,7 +4941,7 @@
           <a:bodyPr wrap="square" rtlCol="0" anchor="ctr"/>
           <a:lstStyle/>
           <a:p>
-            <a:pPr algn="r" indent="0" marL="0">
+            <a:pPr marL="0" indent="0" algn="r">
               <a:buNone/>
             </a:pPr>
             <a:r>
@@ -5095,7 +4980,7 @@
           <a:bodyPr wrap="square" rtlCol="0" anchor="ctr"/>
           <a:lstStyle/>
           <a:p>
-            <a:pPr algn="l" indent="0" marL="0">
+            <a:pPr marL="0" indent="0" algn="l">
               <a:buNone/>
             </a:pPr>
             <a:r>
@@ -5129,6 +5014,7 @@
         <a:solidFill>
           <a:srgbClr val="FFFFFF"/>
         </a:solidFill>
+        <a:effectLst/>
       </p:bgPr>
     </p:bg>
     <p:spTree>
@@ -5166,11 +5052,11 @@
           <a:bodyPr wrap="square" rtlCol="0" anchor="ctr"/>
           <a:lstStyle/>
           <a:p>
-            <a:pPr indent="0" marL="0">
-              <a:buNone/>
-            </a:pPr>
-            <a:r>
-              <a:rPr lang="en-US" sz="1200" b="1" spc="300" kern="0" dirty="0">
+            <a:pPr marL="0" indent="0">
+              <a:buNone/>
+            </a:pPr>
+            <a:r>
+              <a:rPr lang="en-US" sz="1200" b="1" kern="0" spc="300" dirty="0">
                 <a:solidFill>
                   <a:srgbClr val="A26769"/>
                 </a:solidFill>
@@ -5205,7 +5091,7 @@
           <a:bodyPr wrap="square" rtlCol="0" anchor="ctr"/>
           <a:lstStyle/>
           <a:p>
-            <a:pPr indent="0" marL="0">
+            <a:pPr marL="0" indent="0">
               <a:buNone/>
             </a:pPr>
             <a:r>
@@ -5249,13 +5135,20 @@
             <a:prstDash val="solid"/>
           </a:ln>
           <a:effectLst>
-            <a:outerShdw sx="100000" sy="100000" kx="0" ky="0" algn="bl" rotWithShape="0" blurRad="88900" dist="38100" dir="5400000">
+            <a:outerShdw blurRad="88900" dist="38100" dir="5400000" algn="bl" rotWithShape="0">
               <a:srgbClr val="000000">
                 <a:alpha val="14000"/>
               </a:srgbClr>
             </a:outerShdw>
           </a:effectLst>
         </p:spPr>
+        <p:txBody>
+          <a:bodyPr/>
+          <a:lstStyle/>
+          <a:p>
+            <a:endParaRPr lang="de-DE"/>
+          </a:p>
+        </p:txBody>
       </p:sp>
       <p:sp>
         <p:nvSpPr>
@@ -5276,6 +5169,13 @@
           </a:solidFill>
           <a:ln/>
         </p:spPr>
+        <p:txBody>
+          <a:bodyPr/>
+          <a:lstStyle/>
+          <a:p>
+            <a:endParaRPr lang="de-DE"/>
+          </a:p>
+        </p:txBody>
       </p:sp>
       <p:sp>
         <p:nvSpPr>
@@ -5298,7 +5198,7 @@
           <a:bodyPr wrap="square" rtlCol="0" anchor="ctr"/>
           <a:lstStyle/>
           <a:p>
-            <a:pPr algn="ctr" indent="0" marL="0">
+            <a:pPr marL="0" indent="0" algn="ctr">
               <a:buNone/>
             </a:pPr>
             <a:r>
@@ -5337,7 +5237,7 @@
           <a:bodyPr wrap="square" rtlCol="0" anchor="ctr"/>
           <a:lstStyle/>
           <a:p>
-            <a:pPr indent="0" marL="0">
+            <a:pPr marL="0" indent="0">
               <a:buNone/>
             </a:pPr>
             <a:r>
@@ -5376,7 +5276,7 @@
           <a:bodyPr wrap="square" rtlCol="0" anchor="ctr"/>
           <a:lstStyle/>
           <a:p>
-            <a:pPr indent="0" marL="0">
+            <a:pPr marL="0" indent="0">
               <a:buNone/>
             </a:pPr>
             <a:r>
@@ -5415,6 +5315,13 @@
           </a:solidFill>
           <a:ln/>
         </p:spPr>
+        <p:txBody>
+          <a:bodyPr/>
+          <a:lstStyle/>
+          <a:p>
+            <a:endParaRPr lang="de-DE"/>
+          </a:p>
+        </p:txBody>
       </p:sp>
       <p:sp>
         <p:nvSpPr>
@@ -5437,7 +5344,7 @@
           <a:bodyPr wrap="square" rtlCol="0" anchor="ctr"/>
           <a:lstStyle/>
           <a:p>
-            <a:pPr indent="0" marL="0">
+            <a:pPr marL="0" indent="0">
               <a:buNone/>
             </a:pPr>
             <a:r>
@@ -5481,13 +5388,20 @@
             <a:prstDash val="solid"/>
           </a:ln>
           <a:effectLst>
-            <a:outerShdw sx="100000" sy="100000" kx="0" ky="0" algn="bl" rotWithShape="0" blurRad="88900" dist="38100" dir="5400000">
+            <a:outerShdw blurRad="88900" dist="38100" dir="5400000" algn="bl" rotWithShape="0">
               <a:srgbClr val="000000">
                 <a:alpha val="14000"/>
               </a:srgbClr>
             </a:outerShdw>
           </a:effectLst>
         </p:spPr>
+        <p:txBody>
+          <a:bodyPr/>
+          <a:lstStyle/>
+          <a:p>
+            <a:endParaRPr lang="de-DE"/>
+          </a:p>
+        </p:txBody>
       </p:sp>
       <p:sp>
         <p:nvSpPr>
@@ -5508,6 +5422,13 @@
           </a:solidFill>
           <a:ln/>
         </p:spPr>
+        <p:txBody>
+          <a:bodyPr/>
+          <a:lstStyle/>
+          <a:p>
+            <a:endParaRPr lang="de-DE"/>
+          </a:p>
+        </p:txBody>
       </p:sp>
       <p:sp>
         <p:nvSpPr>
@@ -5530,7 +5451,7 @@
           <a:bodyPr wrap="square" rtlCol="0" anchor="ctr"/>
           <a:lstStyle/>
           <a:p>
-            <a:pPr algn="ctr" indent="0" marL="0">
+            <a:pPr marL="0" indent="0" algn="ctr">
               <a:buNone/>
             </a:pPr>
             <a:r>
@@ -5569,7 +5490,7 @@
           <a:bodyPr wrap="square" rtlCol="0" anchor="ctr"/>
           <a:lstStyle/>
           <a:p>
-            <a:pPr indent="0" marL="0">
+            <a:pPr marL="0" indent="0">
               <a:buNone/>
             </a:pPr>
             <a:r>
@@ -5581,7 +5502,7 @@
                 <a:ea typeface="Cambria" pitchFamily="34" charset="-122"/>
                 <a:cs typeface="Cambria" pitchFamily="34" charset="-120"/>
               </a:rPr>
-              <a:t>Metrik-optimierter Schwellenwert</a:t>
+              <a:t>Entscheiden statt runden</a:t>
             </a:r>
             <a:endParaRPr lang="en-US" sz="1800" dirty="0"/>
           </a:p>
@@ -5608,7 +5529,7 @@
           <a:bodyPr wrap="square" rtlCol="0" anchor="ctr"/>
           <a:lstStyle/>
           <a:p>
-            <a:pPr indent="0" marL="0">
+            <a:pPr marL="0" indent="0">
               <a:buNone/>
             </a:pPr>
             <a:r>
@@ -5620,7 +5541,7 @@
                 <a:ea typeface="Calibri" pitchFamily="34" charset="-122"/>
                 <a:cs typeface="Calibri" pitchFamily="34" charset="-120"/>
               </a:rPr>
-              <a:t>Da 75% Fünfer sind, ist normales Runden (bei 4,5) falsch. Wir runden zur 5 schon ab einem Score von 4,3. Das spiegelt die asymmetrischen Kosten der Metrik wider.</a:t>
+              <a:t>Da 75 % Fünfer sind, ist starres Runden falsch. Wir sagen die volle Sterne-Verteilung vorher und wählen pro Paar den Stern mit dem kleinsten erwarteten Fehler.</a:t>
             </a:r>
             <a:endParaRPr lang="en-US" sz="1450" dirty="0"/>
           </a:p>
@@ -5647,6 +5568,13 @@
           </a:solidFill>
           <a:ln/>
         </p:spPr>
+        <p:txBody>
+          <a:bodyPr/>
+          <a:lstStyle/>
+          <a:p>
+            <a:endParaRPr lang="de-DE"/>
+          </a:p>
+        </p:txBody>
       </p:sp>
       <p:sp>
         <p:nvSpPr>
@@ -5669,7 +5597,7 @@
           <a:bodyPr wrap="square" rtlCol="0" anchor="ctr"/>
           <a:lstStyle/>
           <a:p>
-            <a:pPr indent="0" marL="0">
+            <a:pPr marL="0" indent="0">
               <a:buNone/>
             </a:pPr>
             <a:r>
@@ -5681,7 +5609,7 @@
                 <a:ea typeface="Calibri" pitchFamily="34" charset="-122"/>
                 <a:cs typeface="Calibri" pitchFamily="34" charset="-120"/>
               </a:rPr>
-              <a:t>Größter Hebel: Test-MAE 0,305 → 0,29.</a:t>
+              <a:t>Größter Hebel: Test-MAE 0,305 → 0,275.</a:t>
             </a:r>
             <a:endParaRPr lang="en-US" sz="1300" dirty="0"/>
           </a:p>
@@ -5708,7 +5636,7 @@
           <a:bodyPr wrap="square" rtlCol="0" anchor="ctr"/>
           <a:lstStyle/>
           <a:p>
-            <a:pPr algn="r" indent="0" marL="0">
+            <a:pPr marL="0" indent="0" algn="r">
               <a:buNone/>
             </a:pPr>
             <a:r>
@@ -5747,7 +5675,7 @@
           <a:bodyPr wrap="square" rtlCol="0" anchor="ctr"/>
           <a:lstStyle/>
           <a:p>
-            <a:pPr algn="l" indent="0" marL="0">
+            <a:pPr marL="0" indent="0" algn="l">
               <a:buNone/>
             </a:pPr>
             <a:r>
@@ -5781,6 +5709,7 @@
         <a:solidFill>
           <a:srgbClr val="FFFFFF"/>
         </a:solidFill>
+        <a:effectLst/>
       </p:bgPr>
     </p:bg>
     <p:spTree>
@@ -5818,11 +5747,11 @@
           <a:bodyPr wrap="square" rtlCol="0" anchor="ctr"/>
           <a:lstStyle/>
           <a:p>
-            <a:pPr indent="0" marL="0">
-              <a:buNone/>
-            </a:pPr>
-            <a:r>
-              <a:rPr lang="en-US" sz="1200" b="1" spc="300" kern="0" dirty="0">
+            <a:pPr marL="0" indent="0">
+              <a:buNone/>
+            </a:pPr>
+            <a:r>
+              <a:rPr lang="en-US" sz="1200" b="1" kern="0" spc="300" dirty="0">
                 <a:solidFill>
                   <a:srgbClr val="A26769"/>
                 </a:solidFill>
@@ -5857,7 +5786,7 @@
           <a:bodyPr wrap="square" rtlCol="0" anchor="ctr"/>
           <a:lstStyle/>
           <a:p>
-            <a:pPr indent="0" marL="0">
+            <a:pPr marL="0" indent="0">
               <a:buNone/>
             </a:pPr>
             <a:r>
@@ -5896,13 +5825,20 @@
           </a:solidFill>
           <a:ln/>
           <a:effectLst>
-            <a:outerShdw sx="100000" sy="100000" kx="0" ky="0" algn="bl" rotWithShape="0" blurRad="88900" dist="38100" dir="5400000">
+            <a:outerShdw blurRad="88900" dist="38100" dir="5400000" algn="bl" rotWithShape="0">
               <a:srgbClr val="000000">
                 <a:alpha val="14000"/>
               </a:srgbClr>
             </a:outerShdw>
           </a:effectLst>
         </p:spPr>
+        <p:txBody>
+          <a:bodyPr/>
+          <a:lstStyle/>
+          <a:p>
+            <a:endParaRPr lang="de-DE"/>
+          </a:p>
+        </p:txBody>
       </p:sp>
       <p:sp>
         <p:nvSpPr>
@@ -5925,7 +5861,7 @@
           <a:bodyPr wrap="square" rtlCol="0" anchor="ctr"/>
           <a:lstStyle/>
           <a:p>
-            <a:pPr algn="ctr" indent="0" marL="0">
+            <a:pPr marL="0" indent="0" algn="ctr">
               <a:buNone/>
             </a:pPr>
             <a:r>
@@ -5937,7 +5873,7 @@
                 <a:ea typeface="Cambria" pitchFamily="34" charset="-122"/>
                 <a:cs typeface="Cambria" pitchFamily="34" charset="-120"/>
               </a:rPr>
-              <a:t>0,29</a:t>
+              <a:t>0,275</a:t>
             </a:r>
             <a:endParaRPr lang="en-US" sz="6400" dirty="0"/>
           </a:p>
@@ -5964,7 +5900,7 @@
           <a:bodyPr wrap="square" rtlCol="0" anchor="ctr"/>
           <a:lstStyle/>
           <a:p>
-            <a:pPr algn="ctr" indent="0" marL="0">
+            <a:pPr marL="0" indent="0" algn="ctr">
               <a:buNone/>
             </a:pPr>
             <a:r>
@@ -6003,7 +5939,7 @@
           <a:bodyPr wrap="square" rtlCol="0" anchor="ctr"/>
           <a:lstStyle/>
           <a:p>
-            <a:pPr algn="ctr" indent="0" marL="0">
+            <a:pPr marL="0" indent="0" algn="ctr">
               <a:buNone/>
             </a:pPr>
             <a:r>
@@ -6042,7 +5978,7 @@
           <a:bodyPr wrap="square" rtlCol="0" anchor="ctr"/>
           <a:lstStyle/>
           <a:p>
-            <a:pPr algn="ctr" indent="0" marL="0">
+            <a:pPr marL="0" indent="0" algn="ctr">
               <a:buNone/>
             </a:pPr>
             <a:r>
@@ -6059,7 +5995,7 @@
             <a:endParaRPr lang="en-US" sz="1400" dirty="0"/>
           </a:p>
           <a:p>
-            <a:pPr algn="ctr" indent="0" marL="0">
+            <a:pPr marL="0" indent="0" algn="ctr">
               <a:buNone/>
             </a:pPr>
             <a:r>
@@ -6071,7 +6007,29 @@
                 <a:ea typeface="Calibri" pitchFamily="34" charset="-122"/>
                 <a:cs typeface="Calibri" pitchFamily="34" charset="-120"/>
               </a:rPr>
-              <a:t>vs. Kurs-Methoden (v3)  0,31</a:t>
+              <a:t>vs. Kurs-</a:t>
+            </a:r>
+            <a:r>
+              <a:rPr lang="en-US" sz="1400" dirty="0" err="1">
+                <a:solidFill>
+                  <a:srgbClr val="ECE2D0"/>
+                </a:solidFill>
+                <a:latin typeface="Calibri" pitchFamily="34" charset="0"/>
+                <a:ea typeface="Calibri" pitchFamily="34" charset="-122"/>
+                <a:cs typeface="Calibri" pitchFamily="34" charset="-120"/>
+              </a:rPr>
+              <a:t>Methoden</a:t>
+            </a:r>
+            <a:r>
+              <a:rPr lang="en-US" sz="1400" dirty="0">
+                <a:solidFill>
+                  <a:srgbClr val="ECE2D0"/>
+                </a:solidFill>
+                <a:latin typeface="Calibri" pitchFamily="34" charset="0"/>
+                <a:ea typeface="Calibri" pitchFamily="34" charset="-122"/>
+                <a:cs typeface="Calibri" pitchFamily="34" charset="-120"/>
+              </a:rPr>
+              <a:t>  0,31</a:t>
             </a:r>
             <a:endParaRPr lang="en-US" sz="1400" dirty="0"/>
           </a:p>
@@ -6098,7 +6056,7 @@
           <a:bodyPr wrap="square" rtlCol="0" anchor="ctr"/>
           <a:lstStyle/>
           <a:p>
-            <a:pPr indent="0" marL="0">
+            <a:pPr marL="0" indent="0">
               <a:buNone/>
             </a:pPr>
             <a:r>
@@ -6118,7 +6076,7 @@
       </p:sp>
       <p:graphicFrame>
         <p:nvGraphicFramePr>
-          <p:cNvPr id="10" name="Chart 0" descr=""/>
+          <p:cNvPr id="10" name="Chart 0"/>
           <p:cNvGraphicFramePr/>
           <p:nvPr/>
         </p:nvGraphicFramePr>
@@ -6126,9 +6084,9 @@
           <a:off x="4023360" y="2148840"/>
           <a:ext cx="7772400" cy="3657600"/>
         </p:xfrm>
-        <a:graphic xmlns:a="http://schemas.openxmlformats.org/drawingml/2006/main">
+        <a:graphic>
           <a:graphicData uri="http://schemas.openxmlformats.org/drawingml/2006/chart">
-            <c:chart xmlns:c="http://schemas.openxmlformats.org/drawingml/2006/chart" r:id="rId1"/>
+            <c:chart xmlns:c="http://schemas.openxmlformats.org/drawingml/2006/chart" xmlns:r="http://schemas.openxmlformats.org/officeDocument/2006/relationships" r:id="rId3"/>
           </a:graphicData>
         </a:graphic>
       </p:graphicFrame>
@@ -6153,7 +6111,7 @@
           <a:bodyPr wrap="square" rtlCol="0" anchor="ctr"/>
           <a:lstStyle/>
           <a:p>
-            <a:pPr algn="r" indent="0" marL="0">
+            <a:pPr marL="0" indent="0" algn="r">
               <a:buNone/>
             </a:pPr>
             <a:r>
@@ -6192,7 +6150,7 @@
           <a:bodyPr wrap="square" rtlCol="0" anchor="ctr"/>
           <a:lstStyle/>
           <a:p>
-            <a:pPr algn="l" indent="0" marL="0">
+            <a:pPr marL="0" indent="0" algn="l">
               <a:buNone/>
             </a:pPr>
             <a:r>
@@ -6226,6 +6184,7 @@
         <a:solidFill>
           <a:srgbClr val="FFFFFF"/>
         </a:solidFill>
+        <a:effectLst/>
       </p:bgPr>
     </p:bg>
     <p:spTree>
@@ -6263,11 +6222,11 @@
           <a:bodyPr wrap="square" rtlCol="0" anchor="ctr"/>
           <a:lstStyle/>
           <a:p>
-            <a:pPr indent="0" marL="0">
-              <a:buNone/>
-            </a:pPr>
-            <a:r>
-              <a:rPr lang="en-US" sz="1200" b="1" spc="300" kern="0" dirty="0">
+            <a:pPr marL="0" indent="0">
+              <a:buNone/>
+            </a:pPr>
+            <a:r>
+              <a:rPr lang="en-US" sz="1200" b="1" kern="0" spc="300" dirty="0">
                 <a:solidFill>
                   <a:srgbClr val="A26769"/>
                 </a:solidFill>
@@ -6302,7 +6261,7 @@
           <a:bodyPr wrap="square" rtlCol="0" anchor="ctr"/>
           <a:lstStyle/>
           <a:p>
-            <a:pPr indent="0" marL="0">
+            <a:pPr marL="0" indent="0">
               <a:buNone/>
             </a:pPr>
             <a:r>
@@ -6314,7 +6273,7 @@
                 <a:ea typeface="Cambria" pitchFamily="34" charset="-122"/>
                 <a:cs typeface="Cambria" pitchFamily="34" charset="-120"/>
               </a:rPr>
-              <a:t>Wir haben das Limit nachgewiesen</a:t>
+              <a:t>Neun Sackgassen — und ein Durchbruch</a:t>
             </a:r>
             <a:endParaRPr lang="en-US" sz="3000" dirty="0"/>
           </a:p>
@@ -6341,7 +6300,7 @@
           <a:bodyPr wrap="square" rtlCol="0" anchor="ctr"/>
           <a:lstStyle/>
           <a:p>
-            <a:pPr indent="0" marL="0">
+            <a:pPr marL="0" indent="0">
               <a:buNone/>
             </a:pPr>
             <a:r>
@@ -6353,7 +6312,7 @@
                 <a:ea typeface="Calibri" pitchFamily="34" charset="-122"/>
                 <a:cs typeface="Calibri" pitchFamily="34" charset="-120"/>
               </a:rPr>
-              <a:t>Neun Modellfamilien getestet — keine schlägt unseren Ansatz:</a:t>
+              <a:t>Neun Modellfamilien getestet — als „Regression + Rundung“ scheitern alle:</a:t>
             </a:r>
             <a:endParaRPr lang="en-US" sz="1500" dirty="0"/>
           </a:p>
@@ -6380,6 +6339,13 @@
           </a:solidFill>
           <a:ln/>
         </p:spPr>
+        <p:txBody>
+          <a:bodyPr/>
+          <a:lstStyle/>
+          <a:p>
+            <a:endParaRPr lang="de-DE"/>
+          </a:p>
+        </p:txBody>
       </p:sp>
       <p:sp>
         <p:nvSpPr>
@@ -6402,7 +6368,7 @@
           <a:bodyPr wrap="square" rtlCol="0" anchor="ctr"/>
           <a:lstStyle/>
           <a:p>
-            <a:pPr indent="0" marL="0">
+            <a:pPr marL="0" indent="0">
               <a:buNone/>
             </a:pPr>
             <a:r>
@@ -6428,20 +6394,20 @@
         </p:nvSpPr>
         <p:spPr>
           <a:xfrm>
-            <a:off x="2834640" y="2148840"/>
-            <a:ext cx="548640" cy="548640"/>
-          </a:xfrm>
-          <a:prstGeom prst="rect">
-            <a:avLst/>
-          </a:prstGeom>
-          <a:noFill/>
-          <a:ln/>
-        </p:spPr>
-        <p:txBody>
-          <a:bodyPr wrap="square" rtlCol="0" anchor="ctr"/>
-          <a:lstStyle/>
-          <a:p>
-            <a:pPr algn="r" indent="0" marL="0">
+            <a:off x="2834639" y="2148840"/>
+            <a:ext cx="592885" cy="548640"/>
+          </a:xfrm>
+          <a:prstGeom prst="rect">
+            <a:avLst/>
+          </a:prstGeom>
+          <a:noFill/>
+          <a:ln/>
+        </p:spPr>
+        <p:txBody>
+          <a:bodyPr wrap="square" rtlCol="0" anchor="ctr"/>
+          <a:lstStyle/>
+          <a:p>
+            <a:pPr marL="0" indent="0" algn="r">
               <a:buNone/>
             </a:pPr>
             <a:r>
@@ -6480,6 +6446,13 @@
           </a:solidFill>
           <a:ln/>
         </p:spPr>
+        <p:txBody>
+          <a:bodyPr/>
+          <a:lstStyle/>
+          <a:p>
+            <a:endParaRPr lang="de-DE"/>
+          </a:p>
+        </p:txBody>
       </p:sp>
       <p:sp>
         <p:nvSpPr>
@@ -6502,7 +6475,7 @@
           <a:bodyPr wrap="square" rtlCol="0" anchor="ctr"/>
           <a:lstStyle/>
           <a:p>
-            <a:pPr indent="0" marL="0">
+            <a:pPr marL="0" indent="0">
               <a:buNone/>
             </a:pPr>
             <a:r>
@@ -6529,19 +6502,19 @@
         <p:spPr>
           <a:xfrm>
             <a:off x="5943600" y="2148840"/>
-            <a:ext cx="548640" cy="548640"/>
-          </a:xfrm>
-          <a:prstGeom prst="rect">
-            <a:avLst/>
-          </a:prstGeom>
-          <a:noFill/>
-          <a:ln/>
-        </p:spPr>
-        <p:txBody>
-          <a:bodyPr wrap="square" rtlCol="0" anchor="ctr"/>
-          <a:lstStyle/>
-          <a:p>
-            <a:pPr algn="r" indent="0" marL="0">
+            <a:ext cx="576072" cy="548640"/>
+          </a:xfrm>
+          <a:prstGeom prst="rect">
+            <a:avLst/>
+          </a:prstGeom>
+          <a:noFill/>
+          <a:ln/>
+        </p:spPr>
+        <p:txBody>
+          <a:bodyPr wrap="square" rtlCol="0" anchor="ctr"/>
+          <a:lstStyle/>
+          <a:p>
+            <a:pPr marL="0" indent="0" algn="r">
               <a:buNone/>
             </a:pPr>
             <a:r>
@@ -6580,6 +6553,13 @@
           </a:solidFill>
           <a:ln/>
         </p:spPr>
+        <p:txBody>
+          <a:bodyPr/>
+          <a:lstStyle/>
+          <a:p>
+            <a:endParaRPr lang="de-DE"/>
+          </a:p>
+        </p:txBody>
       </p:sp>
       <p:sp>
         <p:nvSpPr>
@@ -6602,7 +6582,7 @@
           <a:bodyPr wrap="square" rtlCol="0" anchor="ctr"/>
           <a:lstStyle/>
           <a:p>
-            <a:pPr indent="0" marL="0">
+            <a:pPr marL="0" indent="0">
               <a:buNone/>
             </a:pPr>
             <a:r>
@@ -6629,19 +6609,19 @@
         <p:spPr>
           <a:xfrm>
             <a:off x="2834640" y="2807208"/>
-            <a:ext cx="548640" cy="548640"/>
-          </a:xfrm>
-          <a:prstGeom prst="rect">
-            <a:avLst/>
-          </a:prstGeom>
-          <a:noFill/>
-          <a:ln/>
-        </p:spPr>
-        <p:txBody>
-          <a:bodyPr wrap="square" rtlCol="0" anchor="ctr"/>
-          <a:lstStyle/>
-          <a:p>
-            <a:pPr algn="r" indent="0" marL="0">
+            <a:ext cx="592884" cy="548640"/>
+          </a:xfrm>
+          <a:prstGeom prst="rect">
+            <a:avLst/>
+          </a:prstGeom>
+          <a:noFill/>
+          <a:ln/>
+        </p:spPr>
+        <p:txBody>
+          <a:bodyPr wrap="square" rtlCol="0" anchor="ctr"/>
+          <a:lstStyle/>
+          <a:p>
+            <a:pPr marL="0" indent="0" algn="r">
               <a:buNone/>
             </a:pPr>
             <a:r>
@@ -6680,6 +6660,13 @@
           </a:solidFill>
           <a:ln/>
         </p:spPr>
+        <p:txBody>
+          <a:bodyPr/>
+          <a:lstStyle/>
+          <a:p>
+            <a:endParaRPr lang="de-DE"/>
+          </a:p>
+        </p:txBody>
       </p:sp>
       <p:sp>
         <p:nvSpPr>
@@ -6702,7 +6689,7 @@
           <a:bodyPr wrap="square" rtlCol="0" anchor="ctr"/>
           <a:lstStyle/>
           <a:p>
-            <a:pPr indent="0" marL="0">
+            <a:pPr marL="0" indent="0">
               <a:buNone/>
             </a:pPr>
             <a:r>
@@ -6729,19 +6716,19 @@
         <p:spPr>
           <a:xfrm>
             <a:off x="5943600" y="2807208"/>
-            <a:ext cx="548640" cy="548640"/>
-          </a:xfrm>
-          <a:prstGeom prst="rect">
-            <a:avLst/>
-          </a:prstGeom>
-          <a:noFill/>
-          <a:ln/>
-        </p:spPr>
-        <p:txBody>
-          <a:bodyPr wrap="square" rtlCol="0" anchor="ctr"/>
-          <a:lstStyle/>
-          <a:p>
-            <a:pPr algn="r" indent="0" marL="0">
+            <a:ext cx="576072" cy="548640"/>
+          </a:xfrm>
+          <a:prstGeom prst="rect">
+            <a:avLst/>
+          </a:prstGeom>
+          <a:noFill/>
+          <a:ln/>
+        </p:spPr>
+        <p:txBody>
+          <a:bodyPr wrap="square" rtlCol="0" anchor="ctr"/>
+          <a:lstStyle/>
+          <a:p>
+            <a:pPr marL="0" indent="0" algn="r">
               <a:buNone/>
             </a:pPr>
             <a:r>
@@ -6780,6 +6767,13 @@
           </a:solidFill>
           <a:ln/>
         </p:spPr>
+        <p:txBody>
+          <a:bodyPr/>
+          <a:lstStyle/>
+          <a:p>
+            <a:endParaRPr lang="de-DE"/>
+          </a:p>
+        </p:txBody>
       </p:sp>
       <p:sp>
         <p:nvSpPr>
@@ -6802,7 +6796,7 @@
           <a:bodyPr wrap="square" rtlCol="0" anchor="ctr"/>
           <a:lstStyle/>
           <a:p>
-            <a:pPr indent="0" marL="0">
+            <a:pPr marL="0" indent="0">
               <a:buNone/>
             </a:pPr>
             <a:r>
@@ -6829,19 +6823,19 @@
         <p:spPr>
           <a:xfrm>
             <a:off x="2834640" y="3465576"/>
-            <a:ext cx="548640" cy="548640"/>
-          </a:xfrm>
-          <a:prstGeom prst="rect">
-            <a:avLst/>
-          </a:prstGeom>
-          <a:noFill/>
-          <a:ln/>
-        </p:spPr>
-        <p:txBody>
-          <a:bodyPr wrap="square" rtlCol="0" anchor="ctr"/>
-          <a:lstStyle/>
-          <a:p>
-            <a:pPr algn="r" indent="0" marL="0">
+            <a:ext cx="592884" cy="548640"/>
+          </a:xfrm>
+          <a:prstGeom prst="rect">
+            <a:avLst/>
+          </a:prstGeom>
+          <a:noFill/>
+          <a:ln/>
+        </p:spPr>
+        <p:txBody>
+          <a:bodyPr wrap="square" rtlCol="0" anchor="ctr"/>
+          <a:lstStyle/>
+          <a:p>
+            <a:pPr marL="0" indent="0" algn="r">
               <a:buNone/>
             </a:pPr>
             <a:r>
@@ -6880,6 +6874,13 @@
           </a:solidFill>
           <a:ln/>
         </p:spPr>
+        <p:txBody>
+          <a:bodyPr/>
+          <a:lstStyle/>
+          <a:p>
+            <a:endParaRPr lang="de-DE"/>
+          </a:p>
+        </p:txBody>
       </p:sp>
       <p:sp>
         <p:nvSpPr>
@@ -6890,19 +6891,19 @@
         <p:spPr>
           <a:xfrm>
             <a:off x="3822192" y="3465576"/>
-            <a:ext cx="2240280" cy="548640"/>
-          </a:xfrm>
-          <a:prstGeom prst="rect">
-            <a:avLst/>
-          </a:prstGeom>
-          <a:noFill/>
-          <a:ln/>
-        </p:spPr>
-        <p:txBody>
-          <a:bodyPr wrap="square" rtlCol="0" anchor="ctr"/>
-          <a:lstStyle/>
-          <a:p>
-            <a:pPr indent="0" marL="0">
+            <a:ext cx="1920240" cy="548640"/>
+          </a:xfrm>
+          <a:prstGeom prst="rect">
+            <a:avLst/>
+          </a:prstGeom>
+          <a:noFill/>
+          <a:ln/>
+        </p:spPr>
+        <p:txBody>
+          <a:bodyPr wrap="square" rtlCol="0" anchor="ctr"/>
+          <a:lstStyle/>
+          <a:p>
+            <a:pPr marL="0" indent="0">
               <a:buNone/>
             </a:pPr>
             <a:r>
@@ -6914,7 +6915,7 @@
                 <a:ea typeface="Calibri" pitchFamily="34" charset="-122"/>
                 <a:cs typeface="Calibri" pitchFamily="34" charset="-120"/>
               </a:rPr>
-              <a:t>Unser Modell (v2)</a:t>
+              <a:t>Unser Weg: v2 → v4</a:t>
             </a:r>
             <a:endParaRPr lang="en-US" sz="1150" dirty="0"/>
           </a:p>
@@ -6928,20 +6929,20 @@
         </p:nvSpPr>
         <p:spPr>
           <a:xfrm>
-            <a:off x="5943600" y="3465576"/>
-            <a:ext cx="548640" cy="548640"/>
-          </a:xfrm>
-          <a:prstGeom prst="rect">
-            <a:avLst/>
-          </a:prstGeom>
-          <a:noFill/>
-          <a:ln/>
-        </p:spPr>
-        <p:txBody>
-          <a:bodyPr wrap="square" rtlCol="0" anchor="ctr"/>
-          <a:lstStyle/>
-          <a:p>
-            <a:pPr algn="r" indent="0" marL="0">
+            <a:off x="5760720" y="3465576"/>
+            <a:ext cx="777240" cy="548640"/>
+          </a:xfrm>
+          <a:prstGeom prst="rect">
+            <a:avLst/>
+          </a:prstGeom>
+          <a:noFill/>
+          <a:ln/>
+        </p:spPr>
+        <p:txBody>
+          <a:bodyPr wrap="square" rtlCol="0" anchor="ctr"/>
+          <a:lstStyle/>
+          <a:p>
+            <a:pPr marL="0" indent="0" algn="r">
               <a:buNone/>
             </a:pPr>
             <a:r>
@@ -6953,7 +6954,7 @@
                 <a:ea typeface="Cambria" pitchFamily="34" charset="-122"/>
                 <a:cs typeface="Cambria" pitchFamily="34" charset="-120"/>
               </a:rPr>
-              <a:t>0,29</a:t>
+              <a:t>0,275</a:t>
             </a:r>
             <a:endParaRPr lang="en-US" sz="1500" dirty="0"/>
           </a:p>
@@ -6980,13 +6981,20 @@
           </a:solidFill>
           <a:ln/>
           <a:effectLst>
-            <a:outerShdw sx="100000" sy="100000" kx="0" ky="0" algn="bl" rotWithShape="0" blurRad="88900" dist="38100" dir="5400000">
+            <a:outerShdw blurRad="88900" dist="38100" dir="5400000" algn="bl" rotWithShape="0">
               <a:srgbClr val="000000">
                 <a:alpha val="14000"/>
               </a:srgbClr>
             </a:outerShdw>
           </a:effectLst>
         </p:spPr>
+        <p:txBody>
+          <a:bodyPr/>
+          <a:lstStyle/>
+          <a:p>
+            <a:endParaRPr lang="de-DE"/>
+          </a:p>
+        </p:txBody>
       </p:sp>
       <p:sp>
         <p:nvSpPr>
@@ -7009,7 +7017,7 @@
           <a:bodyPr wrap="square" rtlCol="0" anchor="ctr"/>
           <a:lstStyle/>
           <a:p>
-            <a:pPr indent="0" marL="0">
+            <a:pPr marL="0" indent="0">
               <a:buNone/>
             </a:pPr>
             <a:r>
@@ -7048,7 +7056,7 @@
           <a:bodyPr wrap="square" rtlCol="0" anchor="ctr"/>
           <a:lstStyle/>
           <a:p>
-            <a:pPr indent="0" marL="0">
+            <a:pPr marL="0" indent="0">
               <a:buNone/>
             </a:pPr>
             <a:r>
@@ -7062,9 +7070,6 @@
               </a:rPr>
               <a:t>60 %</a:t>
             </a:r>
-            <a:pPr indent="0" marL="0">
-              <a:buNone/>
-            </a:pPr>
             <a:r>
               <a:rPr lang="en-US" sz="1450" dirty="0">
                 <a:solidFill>
@@ -7101,7 +7106,7 @@
           <a:bodyPr wrap="square" rtlCol="0" anchor="ctr"/>
           <a:lstStyle/>
           <a:p>
-            <a:pPr indent="0" marL="0">
+            <a:pPr marL="0" indent="0">
               <a:buNone/>
             </a:pPr>
             <a:r>
@@ -7113,7 +7118,7 @@
                 <a:ea typeface="Calibri" pitchFamily="34" charset="-122"/>
                 <a:cs typeface="Calibri" pitchFamily="34" charset="-120"/>
               </a:rPr>
-              <a:t>Diese Unterscheidung ist nur zu ~84% lernbar — wir erreichen bereits 83,5%.</a:t>
+              <a:t>Diese Unterscheidung ist nur zu ~85 % lernbar — unser finales Modell erreicht 85,0 % (v2: 82,8 %).</a:t>
             </a:r>
             <a:endParaRPr lang="en-US" sz="1400" dirty="0"/>
           </a:p>
@@ -7140,7 +7145,7 @@
           <a:bodyPr wrap="square" rtlCol="0" anchor="ctr"/>
           <a:lstStyle/>
           <a:p>
-            <a:pPr indent="0" marL="0">
+            <a:pPr marL="0" indent="0">
               <a:buNone/>
             </a:pPr>
             <a:r>
@@ -7154,9 +7159,6 @@
               </a:rPr>
               <a:t>Der Rest ist </a:t>
             </a:r>
-            <a:pPr indent="0" marL="0">
-              <a:buNone/>
-            </a:pPr>
             <a:r>
               <a:rPr lang="en-US" sz="1400" b="1" dirty="0">
                 <a:solidFill>
@@ -7168,9 +7170,6 @@
               </a:rPr>
               <a:t>irreduzibles Rauschen</a:t>
             </a:r>
-            <a:pPr indent="0" marL="0">
-              <a:buNone/>
-            </a:pPr>
             <a:r>
               <a:rPr lang="en-US" sz="1400" dirty="0">
                 <a:solidFill>
@@ -7207,7 +7206,7 @@
           <a:bodyPr wrap="square" rtlCol="0" anchor="ctr"/>
           <a:lstStyle/>
           <a:p>
-            <a:pPr indent="0" marL="0">
+            <a:pPr marL="0" indent="0">
               <a:buNone/>
             </a:pPr>
             <a:r>
@@ -7219,7 +7218,7 @@
                 <a:ea typeface="Calibri" pitchFamily="34" charset="-122"/>
                 <a:cs typeface="Calibri" pitchFamily="34" charset="-120"/>
               </a:rPr>
-              <a:t>⚠  Gemeldete Werte ≤ 0,25 deuten auf Messfehler (z. B. ohne Rundung / Leakage) hin.</a:t>
+              <a:t>⚠  Stichprobenrauschen ± 0,02 — erst Werte deutlich unter 0,25 sprechen für Messfehler (Rundung, Leakage).</a:t>
             </a:r>
             <a:endParaRPr lang="en-US" sz="1250" dirty="0"/>
           </a:p>
@@ -7246,7 +7245,7 @@
           <a:bodyPr wrap="square" rtlCol="0" anchor="ctr"/>
           <a:lstStyle/>
           <a:p>
-            <a:pPr algn="r" indent="0" marL="0">
+            <a:pPr marL="0" indent="0" algn="r">
               <a:buNone/>
             </a:pPr>
             <a:r>
@@ -7285,7 +7284,7 @@
           <a:bodyPr wrap="square" rtlCol="0" anchor="ctr"/>
           <a:lstStyle/>
           <a:p>
-            <a:pPr algn="l" indent="0" marL="0">
+            <a:pPr marL="0" indent="0" algn="l">
               <a:buNone/>
             </a:pPr>
             <a:r>
@@ -7319,6 +7318,7 @@
         <a:solidFill>
           <a:srgbClr val="6D2E46"/>
         </a:solidFill>
+        <a:effectLst/>
       </p:bgPr>
     </p:bg>
     <p:spTree>
@@ -7354,6 +7354,13 @@
           </a:solidFill>
           <a:ln/>
         </p:spPr>
+        <p:txBody>
+          <a:bodyPr/>
+          <a:lstStyle/>
+          <a:p>
+            <a:endParaRPr lang="de-DE"/>
+          </a:p>
+        </p:txBody>
       </p:sp>
       <p:sp>
         <p:nvSpPr>
@@ -7374,6 +7381,13 @@
           </a:solidFill>
           <a:ln/>
         </p:spPr>
+        <p:txBody>
+          <a:bodyPr/>
+          <a:lstStyle/>
+          <a:p>
+            <a:endParaRPr lang="de-DE"/>
+          </a:p>
+        </p:txBody>
       </p:sp>
       <p:sp>
         <p:nvSpPr>
@@ -7396,11 +7410,11 @@
           <a:bodyPr wrap="square" rtlCol="0" anchor="ctr"/>
           <a:lstStyle/>
           <a:p>
-            <a:pPr indent="0" marL="0">
-              <a:buNone/>
-            </a:pPr>
-            <a:r>
-              <a:rPr lang="en-US" sz="1300" b="1" spc="300" kern="0" dirty="0">
+            <a:pPr marL="0" indent="0">
+              <a:buNone/>
+            </a:pPr>
+            <a:r>
+              <a:rPr lang="en-US" sz="1300" b="1" kern="0" spc="300" dirty="0">
                 <a:solidFill>
                   <a:srgbClr val="A26769"/>
                 </a:solidFill>
@@ -7435,7 +7449,7 @@
           <a:bodyPr wrap="square" rtlCol="0" anchor="ctr"/>
           <a:lstStyle/>
           <a:p>
-            <a:pPr indent="0" marL="0">
+            <a:pPr marL="0" indent="0">
               <a:buNone/>
             </a:pPr>
             <a:r>
@@ -7472,6 +7486,13 @@
           </a:solidFill>
           <a:ln/>
         </p:spPr>
+        <p:txBody>
+          <a:bodyPr/>
+          <a:lstStyle/>
+          <a:p>
+            <a:endParaRPr lang="de-DE"/>
+          </a:p>
+        </p:txBody>
       </p:sp>
       <p:sp>
         <p:nvSpPr>
@@ -7494,7 +7515,7 @@
           <a:bodyPr wrap="square" rtlCol="0" anchor="ctr"/>
           <a:lstStyle/>
           <a:p>
-            <a:pPr indent="0" marL="0">
+            <a:pPr marL="0" indent="0">
               <a:buNone/>
             </a:pPr>
             <a:r>
@@ -7531,6 +7552,13 @@
           </a:solidFill>
           <a:ln/>
         </p:spPr>
+        <p:txBody>
+          <a:bodyPr/>
+          <a:lstStyle/>
+          <a:p>
+            <a:endParaRPr lang="de-DE"/>
+          </a:p>
+        </p:txBody>
       </p:sp>
       <p:sp>
         <p:nvSpPr>
@@ -7553,7 +7581,7 @@
           <a:bodyPr wrap="square" rtlCol="0" anchor="ctr"/>
           <a:lstStyle/>
           <a:p>
-            <a:pPr indent="0" marL="0">
+            <a:pPr marL="0" indent="0">
               <a:buNone/>
             </a:pPr>
             <a:r>
@@ -7565,7 +7593,7 @@
                 <a:ea typeface="Calibri" pitchFamily="34" charset="-122"/>
                 <a:cs typeface="Calibri" pitchFamily="34" charset="-120"/>
               </a:rPr>
-              <a:t>Die Gewinne kommen aus einem weichen Content-Signal und der metrik-gerechten Rundung — nicht aus komplexeren Modellen.</a:t>
+              <a:t>Die Gewinne kommen aus einem weichen Content-Signal und der MAE-optimalen Sterne-Entscheidung pro Paar — nicht aus mehr Modellkomplexität.</a:t>
             </a:r>
             <a:endParaRPr lang="en-US" sz="1550" dirty="0"/>
           </a:p>
@@ -7590,6 +7618,13 @@
           </a:solidFill>
           <a:ln/>
         </p:spPr>
+        <p:txBody>
+          <a:bodyPr/>
+          <a:lstStyle/>
+          <a:p>
+            <a:endParaRPr lang="de-DE"/>
+          </a:p>
+        </p:txBody>
       </p:sp>
       <p:sp>
         <p:nvSpPr>
@@ -7612,7 +7647,7 @@
           <a:bodyPr wrap="square" rtlCol="0" anchor="ctr"/>
           <a:lstStyle/>
           <a:p>
-            <a:pPr indent="0" marL="0">
+            <a:pPr marL="0" indent="0">
               <a:buNone/>
             </a:pPr>
             <a:r>
@@ -7624,7 +7659,7 @@
                 <a:ea typeface="Calibri" pitchFamily="34" charset="-122"/>
                 <a:cs typeface="Calibri" pitchFamily="34" charset="-120"/>
               </a:rPr>
-              <a:t>Test-MAE 0,29 schlägt alle Baselines und die reinen Kurs-Methoden; das Modell generalisiert sauber.</a:t>
+              <a:t>Test-MAE 0,275 schlägt alle Baselines und Kurs-Methoden; Bootstrap und Holdout-Simulationen bestätigen den Vorsprung.</a:t>
             </a:r>
             <a:endParaRPr lang="en-US" sz="1550" dirty="0"/>
           </a:p>
@@ -7649,6 +7684,13 @@
           </a:solidFill>
           <a:ln/>
         </p:spPr>
+        <p:txBody>
+          <a:bodyPr/>
+          <a:lstStyle/>
+          <a:p>
+            <a:endParaRPr lang="de-DE"/>
+          </a:p>
+        </p:txBody>
       </p:sp>
       <p:sp>
         <p:nvSpPr>
@@ -7671,7 +7713,7 @@
           <a:bodyPr wrap="square" rtlCol="0" anchor="ctr"/>
           <a:lstStyle/>
           <a:p>
-            <a:pPr indent="0" marL="0">
+            <a:pPr marL="0" indent="0">
               <a:buNone/>
             </a:pPr>
             <a:r>
@@ -7683,7 +7725,7 @@
                 <a:ea typeface="Calibri" pitchFamily="34" charset="-122"/>
                 <a:cs typeface="Calibri" pitchFamily="34" charset="-120"/>
               </a:rPr>
-              <a:t>Nachweislich nahe am Rauschboden: neun Modellfamilien plateauen, die 4-vs-5-Grenze ist die Grenze.</a:t>
+              <a:t>Nachweislich nahe am Rauschboden: die 4-vs-5-Grenze ist zu ~85 % ausgereizt — mehr geben die Daten nicht her.</a:t>
             </a:r>
             <a:endParaRPr lang="en-US" sz="1550" dirty="0"/>
           </a:p>
@@ -7710,13 +7752,20 @@
           </a:solidFill>
           <a:ln/>
           <a:effectLst>
-            <a:outerShdw sx="100000" sy="100000" kx="0" ky="0" algn="bl" rotWithShape="0" blurRad="88900" dist="38100" dir="5400000">
+            <a:outerShdw blurRad="88900" dist="38100" dir="5400000" algn="bl" rotWithShape="0">
               <a:srgbClr val="000000">
                 <a:alpha val="14000"/>
               </a:srgbClr>
             </a:outerShdw>
           </a:effectLst>
         </p:spPr>
+        <p:txBody>
+          <a:bodyPr/>
+          <a:lstStyle/>
+          <a:p>
+            <a:endParaRPr lang="de-DE"/>
+          </a:p>
+        </p:txBody>
       </p:sp>
       <p:sp>
         <p:nvSpPr>
@@ -7739,7 +7788,7 @@
           <a:bodyPr wrap="square" rtlCol="0" anchor="ctr"/>
           <a:lstStyle/>
           <a:p>
-            <a:pPr algn="ctr" indent="0" marL="0">
+            <a:pPr marL="0" indent="0" algn="ctr">
               <a:buNone/>
             </a:pPr>
             <a:r>
@@ -7751,7 +7800,7 @@
                 <a:ea typeface="Cambria" pitchFamily="34" charset="-122"/>
                 <a:cs typeface="Cambria" pitchFamily="34" charset="-120"/>
               </a:rPr>
-              <a:t>0,29</a:t>
+              <a:t>0,275</a:t>
             </a:r>
             <a:endParaRPr lang="en-US" sz="4400" dirty="0"/>
           </a:p>
@@ -7778,7 +7827,7 @@
           <a:bodyPr wrap="square" rtlCol="0" anchor="ctr"/>
           <a:lstStyle/>
           <a:p>
-            <a:pPr algn="ctr" indent="0" marL="0">
+            <a:pPr marL="0" indent="0" algn="ctr">
               <a:buNone/>
             </a:pPr>
             <a:r>
@@ -7795,7 +7844,7 @@
             <a:endParaRPr lang="en-US" sz="1400" dirty="0"/>
           </a:p>
           <a:p>
-            <a:pPr algn="ctr" indent="0" marL="0">
+            <a:pPr marL="0" indent="0" algn="ctr">
               <a:buNone/>
             </a:pPr>
             <a:r>
@@ -7834,7 +7883,7 @@
           <a:bodyPr wrap="square" rtlCol="0" anchor="ctr"/>
           <a:lstStyle/>
           <a:p>
-            <a:pPr indent="0" marL="0">
+            <a:pPr marL="0" indent="0">
               <a:buNone/>
             </a:pPr>
             <a:r>
@@ -8153,4 +8202,319 @@
     </a:ext>
   </a:extLst>
 </a:theme>
+</file>
+
+<file path=ppt/theme/theme2.xml><?xml version="1.0" encoding="utf-8"?>
+<a:theme xmlns:a="http://schemas.openxmlformats.org/drawingml/2006/main" name="Office">
+  <a:themeElements>
+    <a:clrScheme name="Office">
+      <a:dk1>
+        <a:sysClr val="windowText" lastClr="000000"/>
+      </a:dk1>
+      <a:lt1>
+        <a:sysClr val="window" lastClr="FFFFFF"/>
+      </a:lt1>
+      <a:dk2>
+        <a:srgbClr val="0E2841"/>
+      </a:dk2>
+      <a:lt2>
+        <a:srgbClr val="E8E8E8"/>
+      </a:lt2>
+      <a:accent1>
+        <a:srgbClr val="156082"/>
+      </a:accent1>
+      <a:accent2>
+        <a:srgbClr val="E97132"/>
+      </a:accent2>
+      <a:accent3>
+        <a:srgbClr val="196B24"/>
+      </a:accent3>
+      <a:accent4>
+        <a:srgbClr val="0F9ED5"/>
+      </a:accent4>
+      <a:accent5>
+        <a:srgbClr val="A02B93"/>
+      </a:accent5>
+      <a:accent6>
+        <a:srgbClr val="4EA72E"/>
+      </a:accent6>
+      <a:hlink>
+        <a:srgbClr val="467886"/>
+      </a:hlink>
+      <a:folHlink>
+        <a:srgbClr val="96607D"/>
+      </a:folHlink>
+    </a:clrScheme>
+    <a:fontScheme name="Office">
+      <a:majorFont>
+        <a:latin typeface="Aptos Display" panose="02110004020202020204"/>
+        <a:ea typeface=""/>
+        <a:cs typeface=""/>
+        <a:font script="Jpan" typeface="游ゴシック Light"/>
+        <a:font script="Hang" typeface="맑은 고딕"/>
+        <a:font script="Hans" typeface="等线 Light"/>
+        <a:font script="Hant" typeface="新細明體"/>
+        <a:font script="Arab" typeface="Times New Roman"/>
+        <a:font script="Hebr" typeface="Times New Roman"/>
+        <a:font script="Thai" typeface="Angsana New"/>
+        <a:font script="Ethi" typeface="Nyala"/>
+        <a:font script="Beng" typeface="Vrinda"/>
+        <a:font script="Gujr" typeface="Shruti"/>
+        <a:font script="Khmr" typeface="MoolBoran"/>
+        <a:font script="Knda" typeface="Tunga"/>
+        <a:font script="Guru" typeface="Raavi"/>
+        <a:font script="Cans" typeface="Euphemia"/>
+        <a:font script="Cher" typeface="Plantagenet Cherokee"/>
+        <a:font script="Yiii" typeface="Microsoft Yi Baiti"/>
+        <a:font script="Tibt" typeface="Microsoft Himalaya"/>
+        <a:font script="Thaa" typeface="MV Boli"/>
+        <a:font script="Deva" typeface="Mangal"/>
+        <a:font script="Telu" typeface="Gautami"/>
+        <a:font script="Taml" typeface="Latha"/>
+        <a:font script="Syrc" typeface="Estrangelo Edessa"/>
+        <a:font script="Orya" typeface="Kalinga"/>
+        <a:font script="Mlym" typeface="Kartika"/>
+        <a:font script="Laoo" typeface="DokChampa"/>
+        <a:font script="Sinh" typeface="Iskoola Pota"/>
+        <a:font script="Mong" typeface="Mongolian Baiti"/>
+        <a:font script="Viet" typeface="Times New Roman"/>
+        <a:font script="Uigh" typeface="Microsoft Uighur"/>
+        <a:font script="Geor" typeface="Sylfaen"/>
+        <a:font script="Armn" typeface="Arial"/>
+        <a:font script="Bugi" typeface="Leelawadee UI"/>
+        <a:font script="Bopo" typeface="Microsoft JhengHei"/>
+        <a:font script="Java" typeface="Javanese Text"/>
+        <a:font script="Lisu" typeface="Segoe UI"/>
+        <a:font script="Mymr" typeface="Myanmar Text"/>
+        <a:font script="Nkoo" typeface="Ebrima"/>
+        <a:font script="Olck" typeface="Nirmala UI"/>
+        <a:font script="Osma" typeface="Ebrima"/>
+        <a:font script="Phag" typeface="Phagspa"/>
+        <a:font script="Syrn" typeface="Estrangelo Edessa"/>
+        <a:font script="Syrj" typeface="Estrangelo Edessa"/>
+        <a:font script="Syre" typeface="Estrangelo Edessa"/>
+        <a:font script="Sora" typeface="Nirmala UI"/>
+        <a:font script="Tale" typeface="Microsoft Tai Le"/>
+        <a:font script="Talu" typeface="Microsoft New Tai Lue"/>
+        <a:font script="Tfng" typeface="Ebrima"/>
+      </a:majorFont>
+      <a:minorFont>
+        <a:latin typeface="Aptos" panose="02110004020202020204"/>
+        <a:ea typeface=""/>
+        <a:cs typeface=""/>
+        <a:font script="Jpan" typeface="游ゴシック"/>
+        <a:font script="Hang" typeface="맑은 고딕"/>
+        <a:font script="Hans" typeface="等线"/>
+        <a:font script="Hant" typeface="新細明體"/>
+        <a:font script="Arab" typeface="Arial"/>
+        <a:font script="Hebr" typeface="Arial"/>
+        <a:font script="Thai" typeface="Cordia New"/>
+        <a:font script="Ethi" typeface="Nyala"/>
+        <a:font script="Beng" typeface="Vrinda"/>
+        <a:font script="Gujr" typeface="Shruti"/>
+        <a:font script="Khmr" typeface="DaunPenh"/>
+        <a:font script="Knda" typeface="Tunga"/>
+        <a:font script="Guru" typeface="Raavi"/>
+        <a:font script="Cans" typeface="Euphemia"/>
+        <a:font script="Cher" typeface="Plantagenet Cherokee"/>
+        <a:font script="Yiii" typeface="Microsoft Yi Baiti"/>
+        <a:font script="Tibt" typeface="Microsoft Himalaya"/>
+        <a:font script="Thaa" typeface="MV Boli"/>
+        <a:font script="Deva" typeface="Mangal"/>
+        <a:font script="Telu" typeface="Gautami"/>
+        <a:font script="Taml" typeface="Latha"/>
+        <a:font script="Syrc" typeface="Estrangelo Edessa"/>
+        <a:font script="Orya" typeface="Kalinga"/>
+        <a:font script="Mlym" typeface="Kartika"/>
+        <a:font script="Laoo" typeface="DokChampa"/>
+        <a:font script="Sinh" typeface="Iskoola Pota"/>
+        <a:font script="Mong" typeface="Mongolian Baiti"/>
+        <a:font script="Viet" typeface="Arial"/>
+        <a:font script="Uigh" typeface="Microsoft Uighur"/>
+        <a:font script="Geor" typeface="Sylfaen"/>
+        <a:font script="Armn" typeface="Arial"/>
+        <a:font script="Bugi" typeface="Leelawadee UI"/>
+        <a:font script="Bopo" typeface="Microsoft JhengHei"/>
+        <a:font script="Java" typeface="Javanese Text"/>
+        <a:font script="Lisu" typeface="Segoe UI"/>
+        <a:font script="Mymr" typeface="Myanmar Text"/>
+        <a:font script="Nkoo" typeface="Ebrima"/>
+        <a:font script="Olck" typeface="Nirmala UI"/>
+        <a:font script="Osma" typeface="Ebrima"/>
+        <a:font script="Phag" typeface="Phagspa"/>
+        <a:font script="Syrn" typeface="Estrangelo Edessa"/>
+        <a:font script="Syrj" typeface="Estrangelo Edessa"/>
+        <a:font script="Syre" typeface="Estrangelo Edessa"/>
+        <a:font script="Sora" typeface="Nirmala UI"/>
+        <a:font script="Tale" typeface="Microsoft Tai Le"/>
+        <a:font script="Talu" typeface="Microsoft New Tai Lue"/>
+        <a:font script="Tfng" typeface="Ebrima"/>
+      </a:minorFont>
+    </a:fontScheme>
+    <a:fmtScheme name="Office">
+      <a:fillStyleLst>
+        <a:solidFill>
+          <a:schemeClr val="phClr"/>
+        </a:solidFill>
+        <a:gradFill rotWithShape="1">
+          <a:gsLst>
+            <a:gs pos="0">
+              <a:schemeClr val="phClr">
+                <a:lumMod val="110000"/>
+                <a:satMod val="105000"/>
+                <a:tint val="67000"/>
+              </a:schemeClr>
+            </a:gs>
+            <a:gs pos="50000">
+              <a:schemeClr val="phClr">
+                <a:lumMod val="105000"/>
+                <a:satMod val="103000"/>
+                <a:tint val="73000"/>
+              </a:schemeClr>
+            </a:gs>
+            <a:gs pos="100000">
+              <a:schemeClr val="phClr">
+                <a:lumMod val="105000"/>
+                <a:satMod val="109000"/>
+                <a:tint val="81000"/>
+              </a:schemeClr>
+            </a:gs>
+          </a:gsLst>
+          <a:lin ang="5400000" scaled="0"/>
+        </a:gradFill>
+        <a:gradFill rotWithShape="1">
+          <a:gsLst>
+            <a:gs pos="0">
+              <a:schemeClr val="phClr">
+                <a:satMod val="103000"/>
+                <a:lumMod val="102000"/>
+                <a:tint val="94000"/>
+              </a:schemeClr>
+            </a:gs>
+            <a:gs pos="50000">
+              <a:schemeClr val="phClr">
+                <a:satMod val="110000"/>
+                <a:lumMod val="100000"/>
+                <a:shade val="100000"/>
+              </a:schemeClr>
+            </a:gs>
+            <a:gs pos="100000">
+              <a:schemeClr val="phClr">
+                <a:lumMod val="99000"/>
+                <a:satMod val="120000"/>
+                <a:shade val="78000"/>
+              </a:schemeClr>
+            </a:gs>
+          </a:gsLst>
+          <a:lin ang="5400000" scaled="0"/>
+        </a:gradFill>
+      </a:fillStyleLst>
+      <a:lnStyleLst>
+        <a:ln w="12700" cap="flat" cmpd="sng" algn="ctr">
+          <a:solidFill>
+            <a:schemeClr val="phClr"/>
+          </a:solidFill>
+          <a:prstDash val="solid"/>
+          <a:miter lim="800000"/>
+        </a:ln>
+        <a:ln w="19050" cap="flat" cmpd="sng" algn="ctr">
+          <a:solidFill>
+            <a:schemeClr val="phClr"/>
+          </a:solidFill>
+          <a:prstDash val="solid"/>
+          <a:miter lim="800000"/>
+        </a:ln>
+        <a:ln w="25400" cap="flat" cmpd="sng" algn="ctr">
+          <a:solidFill>
+            <a:schemeClr val="phClr"/>
+          </a:solidFill>
+          <a:prstDash val="solid"/>
+          <a:miter lim="800000"/>
+        </a:ln>
+      </a:lnStyleLst>
+      <a:effectStyleLst>
+        <a:effectStyle>
+          <a:effectLst/>
+        </a:effectStyle>
+        <a:effectStyle>
+          <a:effectLst/>
+        </a:effectStyle>
+        <a:effectStyle>
+          <a:effectLst>
+            <a:outerShdw blurRad="57150" dist="19050" dir="5400000" algn="ctr" rotWithShape="0">
+              <a:srgbClr val="000000">
+                <a:alpha val="63000"/>
+              </a:srgbClr>
+            </a:outerShdw>
+          </a:effectLst>
+        </a:effectStyle>
+      </a:effectStyleLst>
+      <a:bgFillStyleLst>
+        <a:solidFill>
+          <a:schemeClr val="phClr"/>
+        </a:solidFill>
+        <a:solidFill>
+          <a:schemeClr val="phClr">
+            <a:tint val="95000"/>
+            <a:satMod val="170000"/>
+          </a:schemeClr>
+        </a:solidFill>
+        <a:gradFill rotWithShape="1">
+          <a:gsLst>
+            <a:gs pos="0">
+              <a:schemeClr val="phClr">
+                <a:tint val="93000"/>
+                <a:satMod val="150000"/>
+                <a:shade val="98000"/>
+                <a:lumMod val="102000"/>
+              </a:schemeClr>
+            </a:gs>
+            <a:gs pos="50000">
+              <a:schemeClr val="phClr">
+                <a:tint val="98000"/>
+                <a:satMod val="130000"/>
+                <a:shade val="90000"/>
+                <a:lumMod val="103000"/>
+              </a:schemeClr>
+            </a:gs>
+            <a:gs pos="100000">
+              <a:schemeClr val="phClr">
+                <a:shade val="63000"/>
+                <a:satMod val="120000"/>
+              </a:schemeClr>
+            </a:gs>
+          </a:gsLst>
+          <a:lin ang="5400000" scaled="0"/>
+        </a:gradFill>
+      </a:bgFillStyleLst>
+    </a:fmtScheme>
+  </a:themeElements>
+  <a:objectDefaults>
+    <a:lnDef>
+      <a:spPr/>
+      <a:bodyPr/>
+      <a:lstStyle/>
+      <a:style>
+        <a:lnRef idx="2">
+          <a:schemeClr val="accent1"/>
+        </a:lnRef>
+        <a:fillRef idx="0">
+          <a:schemeClr val="accent1"/>
+        </a:fillRef>
+        <a:effectRef idx="1">
+          <a:schemeClr val="accent1"/>
+        </a:effectRef>
+        <a:fontRef idx="minor">
+          <a:schemeClr val="tx1"/>
+        </a:fontRef>
+      </a:style>
+    </a:lnDef>
+  </a:objectDefaults>
+  <a:extraClrSchemeLst/>
+  <a:extLst>
+    <a:ext uri="{05A4C25C-085E-4340-85A3-A5531E510DB2}">
+      <thm15:themeFamily xmlns:thm15="http://schemas.microsoft.com/office/thememl/2012/main" name="Office Theme" id="{2E142A2C-CD16-42D6-873A-C26D2A0506FA}" vid="{1BDDFF52-6CD6-40A5-AB3C-68EB2F1E4D0A}"/>
+    </a:ext>
+  </a:extLst>
+</a:theme>
 </file>
</xml_diff>